<commit_message>
Decks overhaul: dedupe visuals, idempotent inserts, tables, Q+A, agenda, footers, fonts
- Fix integrate_visuals duplicates (title-anchored idempotent inserts, one visual per concept) + atomic save
- generate_decks: Arial/Carlito fonts, EN LTR, title/agenda/answer/table/footer slides, drop redundant V06 slides
- generate_visuals: RTL-left arrows, font constants; glossary 6/slide + Q/A split slides
- add_setup_slide: fix stale L03 marker detection; add check_deck_quality QA gate
- Regenerate all output decks (QA PASS, visuals each found once)
</commit_message>
<xml_diff>
--- a/output/Module02_V10_Updated.pptx
+++ b/output/Module02_V10_Updated.pptx
@@ -9,10 +9,11 @@
     <p:sldId id="257" r:id="rId8"/>
     <p:sldId id="258" r:id="rId9"/>
     <p:sldId id="259" r:id="rId10"/>
+    <p:sldId id="260" r:id="rId11"/>
+    <p:sldId id="264" r:id="rId15"/>
+    <p:sldId id="261" r:id="rId12"/>
+    <p:sldId id="262" r:id="rId13"/>
     <p:sldId id="263" r:id="rId14"/>
-    <p:sldId id="262" r:id="rId13"/>
-    <p:sldId id="260" r:id="rId11"/>
-    <p:sldId id="261" r:id="rId12"/>
   </p:sldIdLst>
   <p:sldSz cx="12191695" cy="6858000" type="screen4x3"/>
   <p:notesSz cx="6858000" cy="9144000"/>
@@ -3111,8 +3112,8 @@
         </p:nvSpPr>
         <p:spPr>
           <a:xfrm>
-            <a:off x="822960" y="1280160"/>
-            <a:ext cx="10515600" cy="731520"/>
+            <a:off x="822960" y="1097280"/>
+            <a:ext cx="10515600" cy="640080"/>
           </a:xfrm>
           <a:prstGeom prst="rect">
             <a:avLst/>
@@ -3125,15 +3126,15 @@
           </a:bodyPr>
           <a:lstStyle/>
           <a:p>
-            <a:pPr algn="r" rtl="1"/>
-            <a:r>
-              <a:rPr sz="3400" b="1">
+            <a:pPr algn="l" rtl="0"/>
+            <a:r>
+              <a:rPr sz="2800" b="1">
                 <a:solidFill>
                   <a:srgbClr val="1F4E79"/>
                 </a:solidFill>
                 <a:latin typeface="Calibri"/>
               </a:rPr>
-              <a:t>V10</a:t>
+              <a:t>Module 02  |  V10</a:t>
             </a:r>
           </a:p>
         </p:txBody>
@@ -3146,7 +3147,7 @@
         </p:nvSpPr>
         <p:spPr>
           <a:xfrm>
-            <a:off x="822960" y="2194560"/>
+            <a:off x="822960" y="1920240"/>
             <a:ext cx="10515600" cy="1097280"/>
           </a:xfrm>
           <a:prstGeom prst="rect">
@@ -3162,11 +3163,11 @@
           <a:p>
             <a:pPr algn="r" rtl="1"/>
             <a:r>
-              <a:rPr sz="4800" b="1">
+              <a:rPr sz="4400" b="1">
                 <a:solidFill>
                   <a:srgbClr val="1F3B5C"/>
                 </a:solidFill>
-                <a:latin typeface="Calibri"/>
+                <a:latin typeface="Arial"/>
               </a:rPr>
               <a:t>تصنيف البيانات على نطاق واسع</a:t>
             </a:r>
@@ -3181,7 +3182,7 @@
         </p:nvSpPr>
         <p:spPr>
           <a:xfrm>
-            <a:off x="822960" y="3566160"/>
+            <a:off x="822960" y="3200400"/>
             <a:ext cx="10515600" cy="914400"/>
           </a:xfrm>
           <a:prstGeom prst="rect">
@@ -3195,9 +3196,9 @@
           </a:bodyPr>
           <a:lstStyle/>
           <a:p>
-            <a:pPr algn="r" rtl="0"/>
-            <a:r>
-              <a:rPr sz="3400" b="0">
+            <a:pPr algn="l" rtl="0"/>
+            <a:r>
+              <a:rPr sz="3000" b="0">
                 <a:solidFill>
                   <a:srgbClr val="333333"/>
                 </a:solidFill>
@@ -3216,7 +3217,7 @@
         </p:nvSpPr>
         <p:spPr>
           <a:xfrm>
-            <a:off x="822960" y="5120640"/>
+            <a:off x="822960" y="4937760"/>
             <a:ext cx="10515600" cy="548640"/>
           </a:xfrm>
           <a:prstGeom prst="rect">
@@ -3236,9 +3237,254 @@
                 <a:solidFill>
                   <a:srgbClr val="666666"/>
                 </a:solidFill>
+                <a:latin typeface="Arial"/>
+              </a:rPr>
+              <a:t>Module 02 — Data &amp; AI Engineering Track  |  الوحدة الثانية</a:t>
+            </a:r>
+          </a:p>
+        </p:txBody>
+      </p:sp>
+      <p:sp>
+        <p:nvSpPr>
+          <p:cNvPr id="6" name="TextBox 5"/>
+          <p:cNvSpPr txBox="1"/>
+          <p:nvPr/>
+        </p:nvSpPr>
+        <p:spPr>
+          <a:xfrm>
+            <a:off x="822960" y="5486400"/>
+            <a:ext cx="10515600" cy="457200"/>
+          </a:xfrm>
+          <a:prstGeom prst="rect">
+            <a:avLst/>
+          </a:prstGeom>
+          <a:noFill/>
+        </p:spPr>
+        <p:txBody>
+          <a:bodyPr wrap="square">
+            <a:spAutoFit/>
+          </a:bodyPr>
+          <a:lstStyle/>
+          <a:p>
+            <a:pPr algn="l" rtl="0"/>
+            <a:r>
+              <a:rPr sz="1400" b="0">
+                <a:solidFill>
+                  <a:srgbClr val="666666"/>
+                </a:solidFill>
                 <a:latin typeface="Calibri"/>
               </a:rPr>
+              <a:t>Light theme  |  Bilingual AR/EN  |  Ready to present</a:t>
+            </a:r>
+          </a:p>
+        </p:txBody>
+      </p:sp>
+      <p:sp>
+        <p:nvSpPr>
+          <p:cNvPr id="7" name="TextBox 6"/>
+          <p:cNvSpPr txBox="1"/>
+          <p:nvPr/>
+        </p:nvSpPr>
+        <p:spPr>
+          <a:xfrm>
+            <a:off x="640080" y="6400800"/>
+            <a:ext cx="8686800" cy="320040"/>
+          </a:xfrm>
+          <a:prstGeom prst="rect">
+            <a:avLst/>
+          </a:prstGeom>
+          <a:noFill/>
+        </p:spPr>
+        <p:txBody>
+          <a:bodyPr wrap="square">
+            <a:spAutoFit/>
+          </a:bodyPr>
+          <a:lstStyle/>
+          <a:p>
+            <a:pPr algn="r" rtl="1"/>
+            <a:r>
+              <a:rPr sz="1000" b="0">
+                <a:solidFill>
+                  <a:srgbClr val="666666"/>
+                </a:solidFill>
+                <a:latin typeface="Arial"/>
+              </a:rPr>
               <a:t>Module 02 — Data &amp; AI Engineering Track  |  الوحدة الثانية</a:t>
+            </a:r>
+          </a:p>
+        </p:txBody>
+      </p:sp>
+      <p:sp>
+        <p:nvSpPr>
+          <p:cNvPr id="8" name="TextBox 7"/>
+          <p:cNvSpPr txBox="1"/>
+          <p:nvPr/>
+        </p:nvSpPr>
+        <p:spPr>
+          <a:xfrm>
+            <a:off x="9601200" y="6400800"/>
+            <a:ext cx="1920240" cy="320040"/>
+          </a:xfrm>
+          <a:prstGeom prst="rect">
+            <a:avLst/>
+          </a:prstGeom>
+          <a:noFill/>
+        </p:spPr>
+        <p:txBody>
+          <a:bodyPr wrap="square">
+            <a:spAutoFit/>
+          </a:bodyPr>
+          <a:lstStyle/>
+          <a:p>
+            <a:pPr algn="l" rtl="0"/>
+            <a:r>
+              <a:rPr sz="1000" b="0">
+                <a:solidFill>
+                  <a:srgbClr val="666666"/>
+                </a:solidFill>
+                <a:latin typeface="Calibri"/>
+              </a:rPr>
+              <a:t>V10  •  1/11</a:t>
+            </a:r>
+          </a:p>
+        </p:txBody>
+      </p:sp>
+      <p:sp>
+        <p:nvSpPr>
+          <p:cNvPr id="9" name="TextBox 8"/>
+          <p:cNvSpPr txBox="1"/>
+          <p:nvPr/>
+        </p:nvSpPr>
+        <p:spPr>
+          <a:xfrm>
+            <a:off x="640080" y="6400800"/>
+            <a:ext cx="8686800" cy="320040"/>
+          </a:xfrm>
+          <a:prstGeom prst="rect">
+            <a:avLst/>
+          </a:prstGeom>
+          <a:noFill/>
+        </p:spPr>
+        <p:txBody>
+          <a:bodyPr wrap="square">
+            <a:spAutoFit/>
+          </a:bodyPr>
+          <a:lstStyle/>
+          <a:p>
+            <a:pPr algn="r" rtl="1"/>
+            <a:r>
+              <a:rPr sz="1000" b="0">
+                <a:solidFill>
+                  <a:srgbClr val="666666"/>
+                </a:solidFill>
+                <a:latin typeface="Arial"/>
+              </a:rPr>
+              <a:t>Module 02 — Data &amp; AI Engineering Track  |  الوحدة الثانية</a:t>
+            </a:r>
+          </a:p>
+        </p:txBody>
+      </p:sp>
+      <p:sp>
+        <p:nvSpPr>
+          <p:cNvPr id="10" name="TextBox 9"/>
+          <p:cNvSpPr txBox="1"/>
+          <p:nvPr/>
+        </p:nvSpPr>
+        <p:spPr>
+          <a:xfrm>
+            <a:off x="9601200" y="6400800"/>
+            <a:ext cx="1920240" cy="320040"/>
+          </a:xfrm>
+          <a:prstGeom prst="rect">
+            <a:avLst/>
+          </a:prstGeom>
+          <a:noFill/>
+        </p:spPr>
+        <p:txBody>
+          <a:bodyPr wrap="square">
+            <a:spAutoFit/>
+          </a:bodyPr>
+          <a:lstStyle/>
+          <a:p>
+            <a:pPr algn="l" rtl="0"/>
+            <a:r>
+              <a:rPr sz="1000" b="0">
+                <a:solidFill>
+                  <a:srgbClr val="666666"/>
+                </a:solidFill>
+                <a:latin typeface="Calibri"/>
+              </a:rPr>
+              <a:t>10_  •  1/9</a:t>
+            </a:r>
+          </a:p>
+        </p:txBody>
+      </p:sp>
+      <p:sp>
+        <p:nvSpPr>
+          <p:cNvPr id="11" name="TextBox 10"/>
+          <p:cNvSpPr txBox="1"/>
+          <p:nvPr/>
+        </p:nvSpPr>
+        <p:spPr>
+          <a:xfrm>
+            <a:off x="640080" y="6400800"/>
+            <a:ext cx="8686800" cy="320040"/>
+          </a:xfrm>
+          <a:prstGeom prst="rect">
+            <a:avLst/>
+          </a:prstGeom>
+          <a:noFill/>
+        </p:spPr>
+        <p:txBody>
+          <a:bodyPr wrap="square">
+            <a:spAutoFit/>
+          </a:bodyPr>
+          <a:lstStyle/>
+          <a:p>
+            <a:pPr algn="r" rtl="1"/>
+            <a:r>
+              <a:rPr sz="1000" b="0">
+                <a:solidFill>
+                  <a:srgbClr val="666666"/>
+                </a:solidFill>
+                <a:latin typeface="Arial"/>
+              </a:rPr>
+              <a:t>Module 02 — Data &amp; AI Engineering Track  |  الوحدة الثانية</a:t>
+            </a:r>
+          </a:p>
+        </p:txBody>
+      </p:sp>
+      <p:sp>
+        <p:nvSpPr>
+          <p:cNvPr id="12" name="TextBox 11"/>
+          <p:cNvSpPr txBox="1"/>
+          <p:nvPr/>
+        </p:nvSpPr>
+        <p:spPr>
+          <a:xfrm>
+            <a:off x="9601200" y="6400800"/>
+            <a:ext cx="1920240" cy="320040"/>
+          </a:xfrm>
+          <a:prstGeom prst="rect">
+            <a:avLst/>
+          </a:prstGeom>
+          <a:noFill/>
+        </p:spPr>
+        <p:txBody>
+          <a:bodyPr wrap="square">
+            <a:spAutoFit/>
+          </a:bodyPr>
+          <a:lstStyle/>
+          <a:p>
+            <a:pPr algn="l" rtl="0"/>
+            <a:r>
+              <a:rPr sz="1000" b="0">
+                <a:solidFill>
+                  <a:srgbClr val="666666"/>
+                </a:solidFill>
+                <a:latin typeface="Calibri"/>
+              </a:rPr>
+              <a:t>10_  •  1/9</a:t>
             </a:r>
           </a:p>
         </p:txBody>
@@ -3343,9 +3589,9 @@
                 <a:solidFill>
                   <a:srgbClr val="1F3B5C"/>
                 </a:solidFill>
-                <a:latin typeface="Calibri"/>
-              </a:rPr>
-              <a:t>لماذا التصنيف؟ / Why Labeling?</a:t>
+                <a:latin typeface="Arial"/>
+              </a:rPr>
+              <a:t>أجندة العرض / Agenda</a:t>
             </a:r>
           </a:p>
         </p:txBody>
@@ -3373,34 +3619,307 @@
           <a:lstStyle/>
           <a:p>
             <a:pPr algn="r" rtl="1">
+              <a:spcBef>
+                <a:spcPts val="200"/>
+              </a:spcBef>
               <a:spcAft>
                 <a:spcPts val="1000"/>
               </a:spcAft>
             </a:pPr>
             <a:r>
-              <a:rPr sz="1900">
+              <a:rPr sz="1600">
                 <a:solidFill>
                   <a:srgbClr val="333333"/>
                 </a:solidFill>
-                <a:latin typeface="Calibri"/>
-              </a:rPr>
-              <a:t>• جودة التصنيفات تحدد سقف أداء أي نموذج تعلّم مُوجَّه.</a:t>
-            </a:r>
-          </a:p>
-          <a:p>
-            <a:pPr algn="r" rtl="0">
+                <a:latin typeface="Arial"/>
+              </a:rPr>
+              <a:t>• V10 — تصنيف البيانات على نطاق واسع</a:t>
+            </a:r>
+          </a:p>
+          <a:p>
+            <a:pPr algn="l" rtl="0">
+              <a:spcBef>
+                <a:spcPts val="200"/>
+              </a:spcBef>
               <a:spcAft>
                 <a:spcPts val="1000"/>
               </a:spcAft>
             </a:pPr>
             <a:r>
-              <a:rPr sz="1900">
+              <a:rPr sz="1300">
                 <a:solidFill>
                   <a:srgbClr val="666666"/>
                 </a:solidFill>
                 <a:latin typeface="Calibri"/>
               </a:rPr>
-              <a:t>   Label quality caps the performance of any supervised model.</a:t>
+              <a:t>• V10 — Labeling at Scale</a:t>
+            </a:r>
+          </a:p>
+          <a:p>
+            <a:pPr algn="r" rtl="1">
+              <a:spcBef>
+                <a:spcPts val="200"/>
+              </a:spcBef>
+              <a:spcAft>
+                <a:spcPts val="1000"/>
+              </a:spcAft>
+            </a:pPr>
+            <a:r>
+              <a:rPr sz="1600">
+                <a:solidFill>
+                  <a:srgbClr val="333333"/>
+                </a:solidFill>
+                <a:latin typeface="Arial"/>
+              </a:rPr>
+              <a:t>• لماذا التصنيف؟ / Why Labeling?</a:t>
+            </a:r>
+          </a:p>
+          <a:p>
+            <a:pPr algn="r" rtl="1">
+              <a:spcBef>
+                <a:spcPts val="200"/>
+              </a:spcBef>
+              <a:spcAft>
+                <a:spcPts val="1000"/>
+              </a:spcAft>
+            </a:pPr>
+            <a:r>
+              <a:rPr sz="1600">
+                <a:solidFill>
+                  <a:srgbClr val="333333"/>
+                </a:solidFill>
+                <a:latin typeface="Arial"/>
+              </a:rPr>
+              <a:t>• الأدوات / Tools</a:t>
+            </a:r>
+          </a:p>
+          <a:p>
+            <a:pPr algn="r" rtl="1">
+              <a:spcBef>
+                <a:spcPts val="200"/>
+              </a:spcBef>
+              <a:spcAft>
+                <a:spcPts val="1000"/>
+              </a:spcAft>
+            </a:pPr>
+            <a:r>
+              <a:rPr sz="1600">
+                <a:solidFill>
+                  <a:srgbClr val="333333"/>
+                </a:solidFill>
+                <a:latin typeface="Arial"/>
+              </a:rPr>
+              <a:t>• التصنيف بمساعدة LLM / LLM-assisted Labeling</a:t>
+            </a:r>
+          </a:p>
+        </p:txBody>
+      </p:sp>
+      <p:sp>
+        <p:nvSpPr>
+          <p:cNvPr id="5" name="TextBox 4"/>
+          <p:cNvSpPr txBox="1"/>
+          <p:nvPr/>
+        </p:nvSpPr>
+        <p:spPr>
+          <a:xfrm>
+            <a:off x="640080" y="6400800"/>
+            <a:ext cx="8686800" cy="320040"/>
+          </a:xfrm>
+          <a:prstGeom prst="rect">
+            <a:avLst/>
+          </a:prstGeom>
+          <a:noFill/>
+        </p:spPr>
+        <p:txBody>
+          <a:bodyPr wrap="square">
+            <a:spAutoFit/>
+          </a:bodyPr>
+          <a:lstStyle/>
+          <a:p>
+            <a:pPr algn="r" rtl="1"/>
+            <a:r>
+              <a:rPr sz="1000" b="0">
+                <a:solidFill>
+                  <a:srgbClr val="666666"/>
+                </a:solidFill>
+                <a:latin typeface="Arial"/>
+              </a:rPr>
+              <a:t>Module 02 — Data &amp; AI Engineering Track  |  الوحدة الثانية</a:t>
+            </a:r>
+          </a:p>
+        </p:txBody>
+      </p:sp>
+      <p:sp>
+        <p:nvSpPr>
+          <p:cNvPr id="6" name="TextBox 5"/>
+          <p:cNvSpPr txBox="1"/>
+          <p:nvPr/>
+        </p:nvSpPr>
+        <p:spPr>
+          <a:xfrm>
+            <a:off x="9601200" y="6400800"/>
+            <a:ext cx="1920240" cy="320040"/>
+          </a:xfrm>
+          <a:prstGeom prst="rect">
+            <a:avLst/>
+          </a:prstGeom>
+          <a:noFill/>
+        </p:spPr>
+        <p:txBody>
+          <a:bodyPr wrap="square">
+            <a:spAutoFit/>
+          </a:bodyPr>
+          <a:lstStyle/>
+          <a:p>
+            <a:pPr algn="l" rtl="0"/>
+            <a:r>
+              <a:rPr sz="1000" b="0">
+                <a:solidFill>
+                  <a:srgbClr val="666666"/>
+                </a:solidFill>
+                <a:latin typeface="Calibri"/>
+              </a:rPr>
+              <a:t>V10  •  2/11</a:t>
+            </a:r>
+          </a:p>
+        </p:txBody>
+      </p:sp>
+      <p:sp>
+        <p:nvSpPr>
+          <p:cNvPr id="7" name="TextBox 6"/>
+          <p:cNvSpPr txBox="1"/>
+          <p:nvPr/>
+        </p:nvSpPr>
+        <p:spPr>
+          <a:xfrm>
+            <a:off x="640080" y="6400800"/>
+            <a:ext cx="8686800" cy="320040"/>
+          </a:xfrm>
+          <a:prstGeom prst="rect">
+            <a:avLst/>
+          </a:prstGeom>
+          <a:noFill/>
+        </p:spPr>
+        <p:txBody>
+          <a:bodyPr wrap="square">
+            <a:spAutoFit/>
+          </a:bodyPr>
+          <a:lstStyle/>
+          <a:p>
+            <a:pPr algn="r" rtl="1"/>
+            <a:r>
+              <a:rPr sz="1000" b="0">
+                <a:solidFill>
+                  <a:srgbClr val="666666"/>
+                </a:solidFill>
+                <a:latin typeface="Arial"/>
+              </a:rPr>
+              <a:t>Module 02 — Data &amp; AI Engineering Track  |  الوحدة الثانية</a:t>
+            </a:r>
+          </a:p>
+        </p:txBody>
+      </p:sp>
+      <p:sp>
+        <p:nvSpPr>
+          <p:cNvPr id="8" name="TextBox 7"/>
+          <p:cNvSpPr txBox="1"/>
+          <p:nvPr/>
+        </p:nvSpPr>
+        <p:spPr>
+          <a:xfrm>
+            <a:off x="9601200" y="6400800"/>
+            <a:ext cx="1920240" cy="320040"/>
+          </a:xfrm>
+          <a:prstGeom prst="rect">
+            <a:avLst/>
+          </a:prstGeom>
+          <a:noFill/>
+        </p:spPr>
+        <p:txBody>
+          <a:bodyPr wrap="square">
+            <a:spAutoFit/>
+          </a:bodyPr>
+          <a:lstStyle/>
+          <a:p>
+            <a:pPr algn="l" rtl="0"/>
+            <a:r>
+              <a:rPr sz="1000" b="0">
+                <a:solidFill>
+                  <a:srgbClr val="666666"/>
+                </a:solidFill>
+                <a:latin typeface="Calibri"/>
+              </a:rPr>
+              <a:t>10_  •  2/9</a:t>
+            </a:r>
+          </a:p>
+        </p:txBody>
+      </p:sp>
+      <p:sp>
+        <p:nvSpPr>
+          <p:cNvPr id="9" name="TextBox 8"/>
+          <p:cNvSpPr txBox="1"/>
+          <p:nvPr/>
+        </p:nvSpPr>
+        <p:spPr>
+          <a:xfrm>
+            <a:off x="640080" y="6400800"/>
+            <a:ext cx="8686800" cy="320040"/>
+          </a:xfrm>
+          <a:prstGeom prst="rect">
+            <a:avLst/>
+          </a:prstGeom>
+          <a:noFill/>
+        </p:spPr>
+        <p:txBody>
+          <a:bodyPr wrap="square">
+            <a:spAutoFit/>
+          </a:bodyPr>
+          <a:lstStyle/>
+          <a:p>
+            <a:pPr algn="r" rtl="1"/>
+            <a:r>
+              <a:rPr sz="1000" b="0">
+                <a:solidFill>
+                  <a:srgbClr val="666666"/>
+                </a:solidFill>
+                <a:latin typeface="Arial"/>
+              </a:rPr>
+              <a:t>Module 02 — Data &amp; AI Engineering Track  |  الوحدة الثانية</a:t>
+            </a:r>
+          </a:p>
+        </p:txBody>
+      </p:sp>
+      <p:sp>
+        <p:nvSpPr>
+          <p:cNvPr id="10" name="TextBox 9"/>
+          <p:cNvSpPr txBox="1"/>
+          <p:nvPr/>
+        </p:nvSpPr>
+        <p:spPr>
+          <a:xfrm>
+            <a:off x="9601200" y="6400800"/>
+            <a:ext cx="1920240" cy="320040"/>
+          </a:xfrm>
+          <a:prstGeom prst="rect">
+            <a:avLst/>
+          </a:prstGeom>
+          <a:noFill/>
+        </p:spPr>
+        <p:txBody>
+          <a:bodyPr wrap="square">
+            <a:spAutoFit/>
+          </a:bodyPr>
+          <a:lstStyle/>
+          <a:p>
+            <a:pPr algn="l" rtl="0"/>
+            <a:r>
+              <a:rPr sz="1000" b="0">
+                <a:solidFill>
+                  <a:srgbClr val="666666"/>
+                </a:solidFill>
+                <a:latin typeface="Calibri"/>
+              </a:rPr>
+              <a:t>10_  •  2/9</a:t>
             </a:r>
           </a:p>
         </p:txBody>
@@ -3505,9 +4024,9 @@
                 <a:solidFill>
                   <a:srgbClr val="1F3B5C"/>
                 </a:solidFill>
-                <a:latin typeface="Calibri"/>
-              </a:rPr>
-              <a:t>الأدوات / Tools</a:t>
+                <a:latin typeface="Arial"/>
+              </a:rPr>
+              <a:t>لماذا التصنيف؟ / Why Labeling?</a:t>
             </a:r>
           </a:p>
         </p:txBody>
@@ -3535,6 +4054,9 @@
           <a:lstStyle/>
           <a:p>
             <a:pPr algn="r" rtl="1">
+              <a:spcBef>
+                <a:spcPts val="200"/>
+              </a:spcBef>
               <a:spcAft>
                 <a:spcPts val="1000"/>
               </a:spcAft>
@@ -3544,25 +4066,238 @@
                 <a:solidFill>
                   <a:srgbClr val="333333"/>
                 </a:solidFill>
-                <a:latin typeface="Calibri"/>
-              </a:rPr>
-              <a:t>• Label Studio للتعددية، Roboflow للرؤية الحاسوبية، Scale AI للتوسع المؤسسي.</a:t>
-            </a:r>
-          </a:p>
-          <a:p>
-            <a:pPr algn="r" rtl="0">
+                <a:latin typeface="Arial"/>
+              </a:rPr>
+              <a:t>• جودة التصنيفات تحدد سقف أداء أي نموذج تعلّم مُوجَّه.</a:t>
+            </a:r>
+          </a:p>
+          <a:p>
+            <a:pPr algn="l" rtl="0">
+              <a:spcBef>
+                <a:spcPts val="200"/>
+              </a:spcBef>
               <a:spcAft>
                 <a:spcPts val="1000"/>
               </a:spcAft>
             </a:pPr>
             <a:r>
-              <a:rPr sz="1900">
+              <a:rPr sz="1600">
                 <a:solidFill>
                   <a:srgbClr val="666666"/>
                 </a:solidFill>
                 <a:latin typeface="Calibri"/>
               </a:rPr>
-              <a:t>   Label Studio for versatility, Roboflow for vision, Scale AI for enterprise scale.</a:t>
+              <a:t>• Label quality caps the performance of any supervised model.</a:t>
+            </a:r>
+          </a:p>
+        </p:txBody>
+      </p:sp>
+      <p:sp>
+        <p:nvSpPr>
+          <p:cNvPr id="5" name="TextBox 4"/>
+          <p:cNvSpPr txBox="1"/>
+          <p:nvPr/>
+        </p:nvSpPr>
+        <p:spPr>
+          <a:xfrm>
+            <a:off x="640080" y="6400800"/>
+            <a:ext cx="8686800" cy="320040"/>
+          </a:xfrm>
+          <a:prstGeom prst="rect">
+            <a:avLst/>
+          </a:prstGeom>
+          <a:noFill/>
+        </p:spPr>
+        <p:txBody>
+          <a:bodyPr wrap="square">
+            <a:spAutoFit/>
+          </a:bodyPr>
+          <a:lstStyle/>
+          <a:p>
+            <a:pPr algn="r" rtl="1"/>
+            <a:r>
+              <a:rPr sz="1000" b="0">
+                <a:solidFill>
+                  <a:srgbClr val="666666"/>
+                </a:solidFill>
+                <a:latin typeface="Arial"/>
+              </a:rPr>
+              <a:t>Module 02 — Data &amp; AI Engineering Track  |  الوحدة الثانية</a:t>
+            </a:r>
+          </a:p>
+        </p:txBody>
+      </p:sp>
+      <p:sp>
+        <p:nvSpPr>
+          <p:cNvPr id="6" name="TextBox 5"/>
+          <p:cNvSpPr txBox="1"/>
+          <p:nvPr/>
+        </p:nvSpPr>
+        <p:spPr>
+          <a:xfrm>
+            <a:off x="9601200" y="6400800"/>
+            <a:ext cx="1920240" cy="320040"/>
+          </a:xfrm>
+          <a:prstGeom prst="rect">
+            <a:avLst/>
+          </a:prstGeom>
+          <a:noFill/>
+        </p:spPr>
+        <p:txBody>
+          <a:bodyPr wrap="square">
+            <a:spAutoFit/>
+          </a:bodyPr>
+          <a:lstStyle/>
+          <a:p>
+            <a:pPr algn="l" rtl="0"/>
+            <a:r>
+              <a:rPr sz="1000" b="0">
+                <a:solidFill>
+                  <a:srgbClr val="666666"/>
+                </a:solidFill>
+                <a:latin typeface="Calibri"/>
+              </a:rPr>
+              <a:t>V10  •  3/11</a:t>
+            </a:r>
+          </a:p>
+        </p:txBody>
+      </p:sp>
+      <p:sp>
+        <p:nvSpPr>
+          <p:cNvPr id="7" name="TextBox 6"/>
+          <p:cNvSpPr txBox="1"/>
+          <p:nvPr/>
+        </p:nvSpPr>
+        <p:spPr>
+          <a:xfrm>
+            <a:off x="640080" y="6400800"/>
+            <a:ext cx="8686800" cy="320040"/>
+          </a:xfrm>
+          <a:prstGeom prst="rect">
+            <a:avLst/>
+          </a:prstGeom>
+          <a:noFill/>
+        </p:spPr>
+        <p:txBody>
+          <a:bodyPr wrap="square">
+            <a:spAutoFit/>
+          </a:bodyPr>
+          <a:lstStyle/>
+          <a:p>
+            <a:pPr algn="r" rtl="1"/>
+            <a:r>
+              <a:rPr sz="1000" b="0">
+                <a:solidFill>
+                  <a:srgbClr val="666666"/>
+                </a:solidFill>
+                <a:latin typeface="Arial"/>
+              </a:rPr>
+              <a:t>Module 02 — Data &amp; AI Engineering Track  |  الوحدة الثانية</a:t>
+            </a:r>
+          </a:p>
+        </p:txBody>
+      </p:sp>
+      <p:sp>
+        <p:nvSpPr>
+          <p:cNvPr id="8" name="TextBox 7"/>
+          <p:cNvSpPr txBox="1"/>
+          <p:nvPr/>
+        </p:nvSpPr>
+        <p:spPr>
+          <a:xfrm>
+            <a:off x="9601200" y="6400800"/>
+            <a:ext cx="1920240" cy="320040"/>
+          </a:xfrm>
+          <a:prstGeom prst="rect">
+            <a:avLst/>
+          </a:prstGeom>
+          <a:noFill/>
+        </p:spPr>
+        <p:txBody>
+          <a:bodyPr wrap="square">
+            <a:spAutoFit/>
+          </a:bodyPr>
+          <a:lstStyle/>
+          <a:p>
+            <a:pPr algn="l" rtl="0"/>
+            <a:r>
+              <a:rPr sz="1000" b="0">
+                <a:solidFill>
+                  <a:srgbClr val="666666"/>
+                </a:solidFill>
+                <a:latin typeface="Calibri"/>
+              </a:rPr>
+              <a:t>10_  •  3/9</a:t>
+            </a:r>
+          </a:p>
+        </p:txBody>
+      </p:sp>
+      <p:sp>
+        <p:nvSpPr>
+          <p:cNvPr id="9" name="TextBox 8"/>
+          <p:cNvSpPr txBox="1"/>
+          <p:nvPr/>
+        </p:nvSpPr>
+        <p:spPr>
+          <a:xfrm>
+            <a:off x="640080" y="6400800"/>
+            <a:ext cx="8686800" cy="320040"/>
+          </a:xfrm>
+          <a:prstGeom prst="rect">
+            <a:avLst/>
+          </a:prstGeom>
+          <a:noFill/>
+        </p:spPr>
+        <p:txBody>
+          <a:bodyPr wrap="square">
+            <a:spAutoFit/>
+          </a:bodyPr>
+          <a:lstStyle/>
+          <a:p>
+            <a:pPr algn="r" rtl="1"/>
+            <a:r>
+              <a:rPr sz="1000" b="0">
+                <a:solidFill>
+                  <a:srgbClr val="666666"/>
+                </a:solidFill>
+                <a:latin typeface="Arial"/>
+              </a:rPr>
+              <a:t>Module 02 — Data &amp; AI Engineering Track  |  الوحدة الثانية</a:t>
+            </a:r>
+          </a:p>
+        </p:txBody>
+      </p:sp>
+      <p:sp>
+        <p:nvSpPr>
+          <p:cNvPr id="10" name="TextBox 9"/>
+          <p:cNvSpPr txBox="1"/>
+          <p:nvPr/>
+        </p:nvSpPr>
+        <p:spPr>
+          <a:xfrm>
+            <a:off x="9601200" y="6400800"/>
+            <a:ext cx="1920240" cy="320040"/>
+          </a:xfrm>
+          <a:prstGeom prst="rect">
+            <a:avLst/>
+          </a:prstGeom>
+          <a:noFill/>
+        </p:spPr>
+        <p:txBody>
+          <a:bodyPr wrap="square">
+            <a:spAutoFit/>
+          </a:bodyPr>
+          <a:lstStyle/>
+          <a:p>
+            <a:pPr algn="l" rtl="0"/>
+            <a:r>
+              <a:rPr sz="1000" b="0">
+                <a:solidFill>
+                  <a:srgbClr val="666666"/>
+                </a:solidFill>
+                <a:latin typeface="Calibri"/>
+              </a:rPr>
+              <a:t>10_  •  3/9</a:t>
             </a:r>
           </a:p>
         </p:txBody>
@@ -3667,9 +4402,9 @@
                 <a:solidFill>
                   <a:srgbClr val="1F3B5C"/>
                 </a:solidFill>
-                <a:latin typeface="Calibri"/>
-              </a:rPr>
-              <a:t>التصنيف بمساعدة LLM / LLM-assisted Labeling</a:t>
+                <a:latin typeface="Arial"/>
+              </a:rPr>
+              <a:t>الأدوات / Tools</a:t>
             </a:r>
           </a:p>
         </p:txBody>
@@ -3697,6 +4432,9 @@
           <a:lstStyle/>
           <a:p>
             <a:pPr algn="r" rtl="1">
+              <a:spcBef>
+                <a:spcPts val="200"/>
+              </a:spcBef>
               <a:spcAft>
                 <a:spcPts val="1000"/>
               </a:spcAft>
@@ -3706,57 +4444,238 @@
                 <a:solidFill>
                   <a:srgbClr val="333333"/>
                 </a:solidFill>
-                <a:latin typeface="Calibri"/>
-              </a:rPr>
-              <a:t>• نموذج لغوي يقترح التصنيفات مبدئيًا لتسريع العملية وخفض التكلفة.</a:t>
-            </a:r>
-          </a:p>
-          <a:p>
-            <a:pPr algn="r" rtl="0">
+                <a:latin typeface="Arial"/>
+              </a:rPr>
+              <a:t>• Label Studio للتعددية، Roboflow للرؤية الحاسوبية، Scale AI للتوسع المؤسسي.</a:t>
+            </a:r>
+          </a:p>
+          <a:p>
+            <a:pPr algn="l" rtl="0">
+              <a:spcBef>
+                <a:spcPts val="200"/>
+              </a:spcBef>
               <a:spcAft>
                 <a:spcPts val="1000"/>
               </a:spcAft>
             </a:pPr>
             <a:r>
-              <a:rPr sz="1900">
+              <a:rPr sz="1600">
                 <a:solidFill>
                   <a:srgbClr val="666666"/>
                 </a:solidFill>
                 <a:latin typeface="Calibri"/>
               </a:rPr>
-              <a:t>   An LLM pre-labels examples to speed up the process and cut cost.</a:t>
-            </a:r>
-          </a:p>
-          <a:p>
-            <a:pPr algn="r" rtl="1">
-              <a:spcAft>
-                <a:spcPts val="1000"/>
-              </a:spcAft>
-            </a:pPr>
-            <a:r>
-              <a:rPr sz="1900">
-                <a:solidFill>
-                  <a:srgbClr val="333333"/>
+              <a:t>• Label Studio for versatility, Roboflow for vision, Scale AI for enterprise scale.</a:t>
+            </a:r>
+          </a:p>
+        </p:txBody>
+      </p:sp>
+      <p:sp>
+        <p:nvSpPr>
+          <p:cNvPr id="5" name="TextBox 4"/>
+          <p:cNvSpPr txBox="1"/>
+          <p:nvPr/>
+        </p:nvSpPr>
+        <p:spPr>
+          <a:xfrm>
+            <a:off x="640080" y="6400800"/>
+            <a:ext cx="8686800" cy="320040"/>
+          </a:xfrm>
+          <a:prstGeom prst="rect">
+            <a:avLst/>
+          </a:prstGeom>
+          <a:noFill/>
+        </p:spPr>
+        <p:txBody>
+          <a:bodyPr wrap="square">
+            <a:spAutoFit/>
+          </a:bodyPr>
+          <a:lstStyle/>
+          <a:p>
+            <a:pPr algn="r" rtl="1"/>
+            <a:r>
+              <a:rPr sz="1000" b="0">
+                <a:solidFill>
+                  <a:srgbClr val="666666"/>
+                </a:solidFill>
+                <a:latin typeface="Arial"/>
+              </a:rPr>
+              <a:t>Module 02 — Data &amp; AI Engineering Track  |  الوحدة الثانية</a:t>
+            </a:r>
+          </a:p>
+        </p:txBody>
+      </p:sp>
+      <p:sp>
+        <p:nvSpPr>
+          <p:cNvPr id="6" name="TextBox 5"/>
+          <p:cNvSpPr txBox="1"/>
+          <p:nvPr/>
+        </p:nvSpPr>
+        <p:spPr>
+          <a:xfrm>
+            <a:off x="9601200" y="6400800"/>
+            <a:ext cx="1920240" cy="320040"/>
+          </a:xfrm>
+          <a:prstGeom prst="rect">
+            <a:avLst/>
+          </a:prstGeom>
+          <a:noFill/>
+        </p:spPr>
+        <p:txBody>
+          <a:bodyPr wrap="square">
+            <a:spAutoFit/>
+          </a:bodyPr>
+          <a:lstStyle/>
+          <a:p>
+            <a:pPr algn="l" rtl="0"/>
+            <a:r>
+              <a:rPr sz="1000" b="0">
+                <a:solidFill>
+                  <a:srgbClr val="666666"/>
                 </a:solidFill>
                 <a:latin typeface="Calibri"/>
               </a:rPr>
-              <a:t>• التحقق البشري (Human-in-the-loop) إلزامي قبل القبول، مع قياس اتفاق النموذج مع البشر.</a:t>
-            </a:r>
-          </a:p>
-          <a:p>
-            <a:pPr algn="r" rtl="0">
-              <a:spcAft>
-                <a:spcPts val="1000"/>
-              </a:spcAft>
-            </a:pPr>
-            <a:r>
-              <a:rPr sz="1900">
+              <a:t>V10  •  4/11</a:t>
+            </a:r>
+          </a:p>
+        </p:txBody>
+      </p:sp>
+      <p:sp>
+        <p:nvSpPr>
+          <p:cNvPr id="7" name="TextBox 6"/>
+          <p:cNvSpPr txBox="1"/>
+          <p:nvPr/>
+        </p:nvSpPr>
+        <p:spPr>
+          <a:xfrm>
+            <a:off x="640080" y="6400800"/>
+            <a:ext cx="8686800" cy="320040"/>
+          </a:xfrm>
+          <a:prstGeom prst="rect">
+            <a:avLst/>
+          </a:prstGeom>
+          <a:noFill/>
+        </p:spPr>
+        <p:txBody>
+          <a:bodyPr wrap="square">
+            <a:spAutoFit/>
+          </a:bodyPr>
+          <a:lstStyle/>
+          <a:p>
+            <a:pPr algn="r" rtl="1"/>
+            <a:r>
+              <a:rPr sz="1000" b="0">
                 <a:solidFill>
                   <a:srgbClr val="666666"/>
                 </a:solidFill>
+                <a:latin typeface="Arial"/>
+              </a:rPr>
+              <a:t>Module 02 — Data &amp; AI Engineering Track  |  الوحدة الثانية</a:t>
+            </a:r>
+          </a:p>
+        </p:txBody>
+      </p:sp>
+      <p:sp>
+        <p:nvSpPr>
+          <p:cNvPr id="8" name="TextBox 7"/>
+          <p:cNvSpPr txBox="1"/>
+          <p:nvPr/>
+        </p:nvSpPr>
+        <p:spPr>
+          <a:xfrm>
+            <a:off x="9601200" y="6400800"/>
+            <a:ext cx="1920240" cy="320040"/>
+          </a:xfrm>
+          <a:prstGeom prst="rect">
+            <a:avLst/>
+          </a:prstGeom>
+          <a:noFill/>
+        </p:spPr>
+        <p:txBody>
+          <a:bodyPr wrap="square">
+            <a:spAutoFit/>
+          </a:bodyPr>
+          <a:lstStyle/>
+          <a:p>
+            <a:pPr algn="l" rtl="0"/>
+            <a:r>
+              <a:rPr sz="1000" b="0">
+                <a:solidFill>
+                  <a:srgbClr val="666666"/>
+                </a:solidFill>
                 <a:latin typeface="Calibri"/>
               </a:rPr>
-              <a:t>   Human-in-the-loop validation is mandatory before acceptance, measuring human–model agreement.</a:t>
+              <a:t>10_  •  4/9</a:t>
+            </a:r>
+          </a:p>
+        </p:txBody>
+      </p:sp>
+      <p:sp>
+        <p:nvSpPr>
+          <p:cNvPr id="9" name="TextBox 8"/>
+          <p:cNvSpPr txBox="1"/>
+          <p:nvPr/>
+        </p:nvSpPr>
+        <p:spPr>
+          <a:xfrm>
+            <a:off x="640080" y="6400800"/>
+            <a:ext cx="8686800" cy="320040"/>
+          </a:xfrm>
+          <a:prstGeom prst="rect">
+            <a:avLst/>
+          </a:prstGeom>
+          <a:noFill/>
+        </p:spPr>
+        <p:txBody>
+          <a:bodyPr wrap="square">
+            <a:spAutoFit/>
+          </a:bodyPr>
+          <a:lstStyle/>
+          <a:p>
+            <a:pPr algn="r" rtl="1"/>
+            <a:r>
+              <a:rPr sz="1000" b="0">
+                <a:solidFill>
+                  <a:srgbClr val="666666"/>
+                </a:solidFill>
+                <a:latin typeface="Arial"/>
+              </a:rPr>
+              <a:t>Module 02 — Data &amp; AI Engineering Track  |  الوحدة الثانية</a:t>
+            </a:r>
+          </a:p>
+        </p:txBody>
+      </p:sp>
+      <p:sp>
+        <p:nvSpPr>
+          <p:cNvPr id="10" name="TextBox 9"/>
+          <p:cNvSpPr txBox="1"/>
+          <p:nvPr/>
+        </p:nvSpPr>
+        <p:spPr>
+          <a:xfrm>
+            <a:off x="9601200" y="6400800"/>
+            <a:ext cx="1920240" cy="320040"/>
+          </a:xfrm>
+          <a:prstGeom prst="rect">
+            <a:avLst/>
+          </a:prstGeom>
+          <a:noFill/>
+        </p:spPr>
+        <p:txBody>
+          <a:bodyPr wrap="square">
+            <a:spAutoFit/>
+          </a:bodyPr>
+          <a:lstStyle/>
+          <a:p>
+            <a:pPr algn="l" rtl="0"/>
+            <a:r>
+              <a:rPr sz="1000" b="0">
+                <a:solidFill>
+                  <a:srgbClr val="666666"/>
+                </a:solidFill>
+                <a:latin typeface="Calibri"/>
+              </a:rPr>
+              <a:t>10_  •  4/9</a:t>
             </a:r>
           </a:p>
         </p:txBody>
@@ -3789,57 +4708,22 @@
       <p:grpSpPr/>
       <p:sp>
         <p:nvSpPr>
-          <p:cNvPr id="2" name="TextBox 1"/>
-          <p:cNvSpPr txBox="1"/>
-          <p:nvPr/>
-        </p:nvSpPr>
-        <p:spPr>
-          <a:xfrm>
-            <a:off x="640080" y="137160"/>
-            <a:ext cx="10972800" cy="640080"/>
-          </a:xfrm>
-          <a:prstGeom prst="rect">
-            <a:avLst/>
-          </a:prstGeom>
-          <a:noFill/>
-        </p:spPr>
-        <p:txBody>
-          <a:bodyPr wrap="none">
-            <a:spAutoFit/>
-          </a:bodyPr>
-          <a:lstStyle/>
-          <a:p>
-            <a:pPr algn="r" rtl="1"/>
-            <a:r>
-              <a:rPr sz="3000" b="1">
-                <a:solidFill>
-                  <a:srgbClr val="1F3B5C"/>
-                </a:solidFill>
-                <a:latin typeface="Calibri"/>
-              </a:rPr>
-              <a:t>سير عمل التصنيف بمساعدة LLM / LLM-assisted Labeling Workflow</a:t>
-            </a:r>
-          </a:p>
-        </p:txBody>
-      </p:sp>
-      <p:sp>
-        <p:nvSpPr>
-          <p:cNvPr id="3" name="Rounded Rectangle 2"/>
+          <p:cNvPr id="2" name="Rectangle 1"/>
           <p:cNvSpPr/>
           <p:nvPr/>
         </p:nvSpPr>
         <p:spPr>
           <a:xfrm>
-            <a:off x="640080" y="2103120"/>
-            <a:ext cx="1965960" cy="1280160"/>
-          </a:xfrm>
-          <a:prstGeom prst="roundRect">
+            <a:off x="0" y="0"/>
+            <a:ext cx="12191695" cy="1005840"/>
+          </a:xfrm>
+          <a:prstGeom prst="rect">
             <a:avLst/>
           </a:prstGeom>
           <a:solidFill>
-            <a:srgbClr val="EDEDED"/>
+            <a:srgbClr val="FFFFFF"/>
           </a:solidFill>
-          <a:ln w="12700">
+          <a:ln w="25400">
             <a:solidFill>
               <a:srgbClr val="1F4E79"/>
             </a:solidFill>
@@ -3861,71 +4745,6 @@
           </a:fontRef>
         </p:style>
         <p:txBody>
-          <a:bodyPr rtlCol="0" anchor="ctr" wrap="square"/>
-          <a:lstStyle/>
-          <a:p>
-            <a:pPr algn="ctr" rtl="1"/>
-            <a:r>
-              <a:rPr sz="1500" b="1">
-                <a:solidFill>
-                  <a:srgbClr val="333333"/>
-                </a:solidFill>
-                <a:latin typeface="Calibri"/>
-              </a:rPr>
-              <a:t>بيانات خام</a:t>
-            </a:r>
-          </a:p>
-          <a:p>
-            <a:pPr algn="ctr" rtl="0"/>
-            <a:r>
-              <a:rPr sz="1200">
-                <a:solidFill>
-                  <a:srgbClr val="666666"/>
-                </a:solidFill>
-                <a:latin typeface="Calibri"/>
-              </a:rPr>
-              <a:t>Raw data</a:t>
-            </a:r>
-          </a:p>
-        </p:txBody>
-      </p:sp>
-      <p:sp>
-        <p:nvSpPr>
-          <p:cNvPr id="4" name="Right Arrow 3"/>
-          <p:cNvSpPr/>
-          <p:nvPr/>
-        </p:nvSpPr>
-        <p:spPr>
-          <a:xfrm>
-            <a:off x="2624328" y="2606040"/>
-            <a:ext cx="274320" cy="274320"/>
-          </a:xfrm>
-          <a:prstGeom prst="rightArrow">
-            <a:avLst/>
-          </a:prstGeom>
-          <a:solidFill>
-            <a:srgbClr val="1F4E79"/>
-          </a:solidFill>
-          <a:ln>
-            <a:noFill/>
-          </a:ln>
-          <a:effectLst/>
-        </p:spPr>
-        <p:style>
-          <a:lnRef idx="1">
-            <a:schemeClr val="accent1"/>
-          </a:lnRef>
-          <a:fillRef idx="3">
-            <a:schemeClr val="accent1"/>
-          </a:fillRef>
-          <a:effectRef idx="2">
-            <a:schemeClr val="accent1"/>
-          </a:effectRef>
-          <a:fontRef idx="minor">
-            <a:schemeClr val="lt1"/>
-          </a:fontRef>
-        </p:style>
-        <p:txBody>
           <a:bodyPr rtlCol="0" anchor="ctr"/>
           <a:lstStyle/>
           <a:p>
@@ -3935,481 +4754,14 @@
       </p:sp>
       <p:sp>
         <p:nvSpPr>
-          <p:cNvPr id="5" name="Rounded Rectangle 4"/>
-          <p:cNvSpPr/>
-          <p:nvPr/>
-        </p:nvSpPr>
-        <p:spPr>
-          <a:xfrm>
-            <a:off x="2926080" y="2103120"/>
-            <a:ext cx="1965960" cy="1280160"/>
-          </a:xfrm>
-          <a:prstGeom prst="roundRect">
-            <a:avLst/>
-          </a:prstGeom>
-          <a:solidFill>
-            <a:srgbClr val="DCE6F1"/>
-          </a:solidFill>
-          <a:ln w="12700">
-            <a:solidFill>
-              <a:srgbClr val="1F4E79"/>
-            </a:solidFill>
-          </a:ln>
-          <a:effectLst/>
-        </p:spPr>
-        <p:style>
-          <a:lnRef idx="1">
-            <a:schemeClr val="accent1"/>
-          </a:lnRef>
-          <a:fillRef idx="3">
-            <a:schemeClr val="accent1"/>
-          </a:fillRef>
-          <a:effectRef idx="2">
-            <a:schemeClr val="accent1"/>
-          </a:effectRef>
-          <a:fontRef idx="minor">
-            <a:schemeClr val="lt1"/>
-          </a:fontRef>
-        </p:style>
-        <p:txBody>
-          <a:bodyPr rtlCol="0" anchor="ctr" wrap="square"/>
-          <a:lstStyle/>
-          <a:p>
-            <a:pPr algn="ctr" rtl="1"/>
-            <a:r>
-              <a:rPr sz="1500" b="1">
-                <a:solidFill>
-                  <a:srgbClr val="333333"/>
-                </a:solidFill>
-                <a:latin typeface="Calibri"/>
-              </a:rPr>
-              <a:t>تسمية مبدئية بالـ LLM</a:t>
-            </a:r>
-          </a:p>
-          <a:p>
-            <a:pPr algn="ctr" rtl="0"/>
-            <a:r>
-              <a:rPr sz="1200">
-                <a:solidFill>
-                  <a:srgbClr val="666666"/>
-                </a:solidFill>
-                <a:latin typeface="Calibri"/>
-              </a:rPr>
-              <a:t>LLM pre-labeling</a:t>
-            </a:r>
-          </a:p>
-        </p:txBody>
-      </p:sp>
-      <p:sp>
-        <p:nvSpPr>
-          <p:cNvPr id="6" name="Right Arrow 5"/>
-          <p:cNvSpPr/>
-          <p:nvPr/>
-        </p:nvSpPr>
-        <p:spPr>
-          <a:xfrm>
-            <a:off x="4910328" y="2606040"/>
-            <a:ext cx="274320" cy="274320"/>
-          </a:xfrm>
-          <a:prstGeom prst="rightArrow">
-            <a:avLst/>
-          </a:prstGeom>
-          <a:solidFill>
-            <a:srgbClr val="1F4E79"/>
-          </a:solidFill>
-          <a:ln>
-            <a:noFill/>
-          </a:ln>
-          <a:effectLst/>
-        </p:spPr>
-        <p:style>
-          <a:lnRef idx="1">
-            <a:schemeClr val="accent1"/>
-          </a:lnRef>
-          <a:fillRef idx="3">
-            <a:schemeClr val="accent1"/>
-          </a:fillRef>
-          <a:effectRef idx="2">
-            <a:schemeClr val="accent1"/>
-          </a:effectRef>
-          <a:fontRef idx="minor">
-            <a:schemeClr val="lt1"/>
-          </a:fontRef>
-        </p:style>
-        <p:txBody>
-          <a:bodyPr rtlCol="0" anchor="ctr"/>
-          <a:lstStyle/>
-          <a:p>
-            <a:pPr algn="ctr"/>
-          </a:p>
-        </p:txBody>
-      </p:sp>
-      <p:sp>
-        <p:nvSpPr>
-          <p:cNvPr id="7" name="Rounded Rectangle 6"/>
-          <p:cNvSpPr/>
-          <p:nvPr/>
-        </p:nvSpPr>
-        <p:spPr>
-          <a:xfrm>
-            <a:off x="5212080" y="2103120"/>
-            <a:ext cx="1965960" cy="1280160"/>
-          </a:xfrm>
-          <a:prstGeom prst="roundRect">
-            <a:avLst/>
-          </a:prstGeom>
-          <a:solidFill>
-            <a:srgbClr val="E2EFDA"/>
-          </a:solidFill>
-          <a:ln w="12700">
-            <a:solidFill>
-              <a:srgbClr val="1F4E79"/>
-            </a:solidFill>
-          </a:ln>
-          <a:effectLst/>
-        </p:spPr>
-        <p:style>
-          <a:lnRef idx="1">
-            <a:schemeClr val="accent1"/>
-          </a:lnRef>
-          <a:fillRef idx="3">
-            <a:schemeClr val="accent1"/>
-          </a:fillRef>
-          <a:effectRef idx="2">
-            <a:schemeClr val="accent1"/>
-          </a:effectRef>
-          <a:fontRef idx="minor">
-            <a:schemeClr val="lt1"/>
-          </a:fontRef>
-        </p:style>
-        <p:txBody>
-          <a:bodyPr rtlCol="0" anchor="ctr" wrap="square"/>
-          <a:lstStyle/>
-          <a:p>
-            <a:pPr algn="ctr" rtl="1"/>
-            <a:r>
-              <a:rPr sz="1500" b="1">
-                <a:solidFill>
-                  <a:srgbClr val="333333"/>
-                </a:solidFill>
-                <a:latin typeface="Calibri"/>
-              </a:rPr>
-              <a:t>مراجعة وتصحيح بشري</a:t>
-            </a:r>
-          </a:p>
-          <a:p>
-            <a:pPr algn="ctr" rtl="0"/>
-            <a:r>
-              <a:rPr sz="1200">
-                <a:solidFill>
-                  <a:srgbClr val="666666"/>
-                </a:solidFill>
-                <a:latin typeface="Calibri"/>
-              </a:rPr>
-              <a:t>Human review (HITL)</a:t>
-            </a:r>
-          </a:p>
-        </p:txBody>
-      </p:sp>
-      <p:sp>
-        <p:nvSpPr>
-          <p:cNvPr id="8" name="Right Arrow 7"/>
-          <p:cNvSpPr/>
-          <p:nvPr/>
-        </p:nvSpPr>
-        <p:spPr>
-          <a:xfrm>
-            <a:off x="7196328" y="2606040"/>
-            <a:ext cx="274320" cy="274320"/>
-          </a:xfrm>
-          <a:prstGeom prst="rightArrow">
-            <a:avLst/>
-          </a:prstGeom>
-          <a:solidFill>
-            <a:srgbClr val="1F4E79"/>
-          </a:solidFill>
-          <a:ln>
-            <a:noFill/>
-          </a:ln>
-          <a:effectLst/>
-        </p:spPr>
-        <p:style>
-          <a:lnRef idx="1">
-            <a:schemeClr val="accent1"/>
-          </a:lnRef>
-          <a:fillRef idx="3">
-            <a:schemeClr val="accent1"/>
-          </a:fillRef>
-          <a:effectRef idx="2">
-            <a:schemeClr val="accent1"/>
-          </a:effectRef>
-          <a:fontRef idx="minor">
-            <a:schemeClr val="lt1"/>
-          </a:fontRef>
-        </p:style>
-        <p:txBody>
-          <a:bodyPr rtlCol="0" anchor="ctr"/>
-          <a:lstStyle/>
-          <a:p>
-            <a:pPr algn="ctr"/>
-          </a:p>
-        </p:txBody>
-      </p:sp>
-      <p:sp>
-        <p:nvSpPr>
-          <p:cNvPr id="9" name="Rounded Rectangle 8"/>
-          <p:cNvSpPr/>
-          <p:nvPr/>
-        </p:nvSpPr>
-        <p:spPr>
-          <a:xfrm>
-            <a:off x="7498080" y="2103120"/>
-            <a:ext cx="1965960" cy="1280160"/>
-          </a:xfrm>
-          <a:prstGeom prst="roundRect">
-            <a:avLst/>
-          </a:prstGeom>
-          <a:solidFill>
-            <a:srgbClr val="FDE9D9"/>
-          </a:solidFill>
-          <a:ln w="12700">
-            <a:solidFill>
-              <a:srgbClr val="1F4E79"/>
-            </a:solidFill>
-          </a:ln>
-          <a:effectLst/>
-        </p:spPr>
-        <p:style>
-          <a:lnRef idx="1">
-            <a:schemeClr val="accent1"/>
-          </a:lnRef>
-          <a:fillRef idx="3">
-            <a:schemeClr val="accent1"/>
-          </a:fillRef>
-          <a:effectRef idx="2">
-            <a:schemeClr val="accent1"/>
-          </a:effectRef>
-          <a:fontRef idx="minor">
-            <a:schemeClr val="lt1"/>
-          </a:fontRef>
-        </p:style>
-        <p:txBody>
-          <a:bodyPr rtlCol="0" anchor="ctr" wrap="square"/>
-          <a:lstStyle/>
-          <a:p>
-            <a:pPr algn="ctr" rtl="1"/>
-            <a:r>
-              <a:rPr sz="1500" b="1">
-                <a:solidFill>
-                  <a:srgbClr val="333333"/>
-                </a:solidFill>
-                <a:latin typeface="Calibri"/>
-              </a:rPr>
-              <a:t>تسميات معتمدة</a:t>
-            </a:r>
-          </a:p>
-          <a:p>
-            <a:pPr algn="ctr" rtl="0"/>
-            <a:r>
-              <a:rPr sz="1200">
-                <a:solidFill>
-                  <a:srgbClr val="666666"/>
-                </a:solidFill>
-                <a:latin typeface="Calibri"/>
-              </a:rPr>
-              <a:t>Approved labels</a:t>
-            </a:r>
-          </a:p>
-        </p:txBody>
-      </p:sp>
-      <p:sp>
-        <p:nvSpPr>
-          <p:cNvPr id="10" name="Right Arrow 9"/>
-          <p:cNvSpPr/>
-          <p:nvPr/>
-        </p:nvSpPr>
-        <p:spPr>
-          <a:xfrm>
-            <a:off x="9482328" y="2606040"/>
-            <a:ext cx="274320" cy="274320"/>
-          </a:xfrm>
-          <a:prstGeom prst="rightArrow">
-            <a:avLst/>
-          </a:prstGeom>
-          <a:solidFill>
-            <a:srgbClr val="1F4E79"/>
-          </a:solidFill>
-          <a:ln>
-            <a:noFill/>
-          </a:ln>
-          <a:effectLst/>
-        </p:spPr>
-        <p:style>
-          <a:lnRef idx="1">
-            <a:schemeClr val="accent1"/>
-          </a:lnRef>
-          <a:fillRef idx="3">
-            <a:schemeClr val="accent1"/>
-          </a:fillRef>
-          <a:effectRef idx="2">
-            <a:schemeClr val="accent1"/>
-          </a:effectRef>
-          <a:fontRef idx="minor">
-            <a:schemeClr val="lt1"/>
-          </a:fontRef>
-        </p:style>
-        <p:txBody>
-          <a:bodyPr rtlCol="0" anchor="ctr"/>
-          <a:lstStyle/>
-          <a:p>
-            <a:pPr algn="ctr"/>
-          </a:p>
-        </p:txBody>
-      </p:sp>
-      <p:sp>
-        <p:nvSpPr>
-          <p:cNvPr id="11" name="Rounded Rectangle 10"/>
-          <p:cNvSpPr/>
-          <p:nvPr/>
-        </p:nvSpPr>
-        <p:spPr>
-          <a:xfrm>
-            <a:off x="9784080" y="2103120"/>
-            <a:ext cx="1965960" cy="1280160"/>
-          </a:xfrm>
-          <a:prstGeom prst="roundRect">
-            <a:avLst/>
-          </a:prstGeom>
-          <a:solidFill>
-            <a:srgbClr val="EDEDED"/>
-          </a:solidFill>
-          <a:ln w="12700">
-            <a:solidFill>
-              <a:srgbClr val="1F4E79"/>
-            </a:solidFill>
-          </a:ln>
-          <a:effectLst/>
-        </p:spPr>
-        <p:style>
-          <a:lnRef idx="1">
-            <a:schemeClr val="accent1"/>
-          </a:lnRef>
-          <a:fillRef idx="3">
-            <a:schemeClr val="accent1"/>
-          </a:fillRef>
-          <a:effectRef idx="2">
-            <a:schemeClr val="accent1"/>
-          </a:effectRef>
-          <a:fontRef idx="minor">
-            <a:schemeClr val="lt1"/>
-          </a:fontRef>
-        </p:style>
-        <p:txBody>
-          <a:bodyPr rtlCol="0" anchor="ctr" wrap="square"/>
-          <a:lstStyle/>
-          <a:p>
-            <a:pPr algn="ctr" rtl="1"/>
-            <a:r>
-              <a:rPr sz="1500" b="1">
-                <a:solidFill>
-                  <a:srgbClr val="333333"/>
-                </a:solidFill>
-                <a:latin typeface="Calibri"/>
-              </a:rPr>
-              <a:t>تدريب النموذج</a:t>
-            </a:r>
-          </a:p>
-          <a:p>
-            <a:pPr algn="ctr" rtl="0"/>
-            <a:r>
-              <a:rPr sz="1200">
-                <a:solidFill>
-                  <a:srgbClr val="666666"/>
-                </a:solidFill>
-                <a:latin typeface="Calibri"/>
-              </a:rPr>
-              <a:t>Model training</a:t>
-            </a:r>
-          </a:p>
-        </p:txBody>
-      </p:sp>
-      <p:sp>
-        <p:nvSpPr>
-          <p:cNvPr id="12" name="Rounded Rectangle 11"/>
-          <p:cNvSpPr/>
-          <p:nvPr/>
-        </p:nvSpPr>
-        <p:spPr>
-          <a:xfrm>
-            <a:off x="2743200" y="4023360"/>
-            <a:ext cx="6766560" cy="731520"/>
-          </a:xfrm>
-          <a:prstGeom prst="roundRect">
-            <a:avLst/>
-          </a:prstGeom>
-          <a:solidFill>
-            <a:srgbClr val="EDEDED"/>
-          </a:solidFill>
-          <a:ln w="12700">
-            <a:solidFill>
-              <a:srgbClr val="1F4E79"/>
-            </a:solidFill>
-          </a:ln>
-          <a:effectLst/>
-        </p:spPr>
-        <p:style>
-          <a:lnRef idx="1">
-            <a:schemeClr val="accent1"/>
-          </a:lnRef>
-          <a:fillRef idx="3">
-            <a:schemeClr val="accent1"/>
-          </a:fillRef>
-          <a:effectRef idx="2">
-            <a:schemeClr val="accent1"/>
-          </a:effectRef>
-          <a:fontRef idx="minor">
-            <a:schemeClr val="lt1"/>
-          </a:fontRef>
-        </p:style>
-        <p:txBody>
-          <a:bodyPr rtlCol="0" anchor="ctr" wrap="square"/>
-          <a:lstStyle/>
-          <a:p>
-            <a:pPr algn="ctr" rtl="1"/>
-            <a:r>
-              <a:rPr sz="1300" b="1">
-                <a:solidFill>
-                  <a:srgbClr val="333333"/>
-                </a:solidFill>
-                <a:latin typeface="Calibri"/>
-              </a:rPr>
-              <a:t>حلقة تغذية راجعة: تصحيحات البشر تُحسِّن موجِّهات الـ LLM</a:t>
-            </a:r>
-          </a:p>
-          <a:p>
-            <a:pPr algn="ctr" rtl="0"/>
-            <a:r>
-              <a:rPr sz="1100">
-                <a:solidFill>
-                  <a:srgbClr val="666666"/>
-                </a:solidFill>
-                <a:latin typeface="Calibri"/>
-              </a:rPr>
-              <a:t>Feedback loop: human corrections improve LLM prompts</a:t>
-            </a:r>
-          </a:p>
-        </p:txBody>
-      </p:sp>
-      <p:sp>
-        <p:nvSpPr>
-          <p:cNvPr id="13" name="TextBox 12"/>
+          <p:cNvPr id="3" name="TextBox 2"/>
           <p:cNvSpPr txBox="1"/>
           <p:nvPr/>
         </p:nvSpPr>
         <p:spPr>
           <a:xfrm>
-            <a:off x="640080" y="6126480"/>
-            <a:ext cx="10972800" cy="548640"/>
+            <a:off x="640080" y="182880"/>
+            <a:ext cx="10972800" cy="640080"/>
           </a:xfrm>
           <a:prstGeom prst="rect">
             <a:avLst/>
@@ -4424,19 +4776,322 @@
           <a:p>
             <a:pPr algn="r" rtl="1"/>
             <a:r>
-              <a:rPr sz="1400">
+              <a:rPr sz="3200" b="1">
+                <a:solidFill>
+                  <a:srgbClr val="1F3B5C"/>
+                </a:solidFill>
+                <a:latin typeface="Arial"/>
+              </a:rPr>
+              <a:t>التصنيف بمساعدة LLM / LLM-assisted Labeling</a:t>
+            </a:r>
+          </a:p>
+        </p:txBody>
+      </p:sp>
+      <p:sp>
+        <p:nvSpPr>
+          <p:cNvPr id="4" name="TextBox 3"/>
+          <p:cNvSpPr txBox="1"/>
+          <p:nvPr/>
+        </p:nvSpPr>
+        <p:spPr>
+          <a:xfrm>
+            <a:off x="640080" y="1280160"/>
+            <a:ext cx="10972800" cy="5212080"/>
+          </a:xfrm>
+          <a:prstGeom prst="rect">
+            <a:avLst/>
+          </a:prstGeom>
+          <a:noFill/>
+        </p:spPr>
+        <p:txBody>
+          <a:bodyPr wrap="square">
+            <a:spAutoFit/>
+          </a:bodyPr>
+          <a:lstStyle/>
+          <a:p>
+            <a:pPr algn="r" rtl="1">
+              <a:spcBef>
+                <a:spcPts val="200"/>
+              </a:spcBef>
+              <a:spcAft>
+                <a:spcPts val="1000"/>
+              </a:spcAft>
+            </a:pPr>
+            <a:r>
+              <a:rPr sz="1900">
+                <a:solidFill>
+                  <a:srgbClr val="333333"/>
+                </a:solidFill>
+                <a:latin typeface="Arial"/>
+              </a:rPr>
+              <a:t>• نموذج لغوي يقترح التصنيفات مبدئيًا لتسريع العملية وخفض التكلفة.</a:t>
+            </a:r>
+          </a:p>
+          <a:p>
+            <a:pPr algn="l" rtl="0">
+              <a:spcBef>
+                <a:spcPts val="200"/>
+              </a:spcBef>
+              <a:spcAft>
+                <a:spcPts val="1000"/>
+              </a:spcAft>
+            </a:pPr>
+            <a:r>
+              <a:rPr sz="1600">
                 <a:solidFill>
                   <a:srgbClr val="666666"/>
                 </a:solidFill>
                 <a:latin typeface="Calibri"/>
               </a:rPr>
-              <a:t>الـ LLM يسرّع التسمية والبشر يضمنون الجودة — أفضل الممارسات الحديثة.</a:t>
-            </a:r>
-          </a:p>
-          <a:p>
-            <a:pPr algn="r" rtl="0"/>
-            <a:r>
-              <a:t>LLM accelerates labeling; humans guarantee quality — modern best practice.</a:t>
+              <a:t>• An LLM pre-labels examples to speed up the process and cut cost.</a:t>
+            </a:r>
+          </a:p>
+          <a:p>
+            <a:pPr algn="r" rtl="1">
+              <a:spcBef>
+                <a:spcPts val="200"/>
+              </a:spcBef>
+              <a:spcAft>
+                <a:spcPts val="1000"/>
+              </a:spcAft>
+            </a:pPr>
+            <a:r>
+              <a:rPr sz="1900">
+                <a:solidFill>
+                  <a:srgbClr val="333333"/>
+                </a:solidFill>
+                <a:latin typeface="Arial"/>
+              </a:rPr>
+              <a:t>• التحقق البشري (Human-in-the-loop) إلزامي قبل القبول، مع قياس اتفاق النموذج مع البشر.</a:t>
+            </a:r>
+          </a:p>
+          <a:p>
+            <a:pPr algn="l" rtl="0">
+              <a:spcBef>
+                <a:spcPts val="200"/>
+              </a:spcBef>
+              <a:spcAft>
+                <a:spcPts val="1000"/>
+              </a:spcAft>
+            </a:pPr>
+            <a:r>
+              <a:rPr sz="1600">
+                <a:solidFill>
+                  <a:srgbClr val="666666"/>
+                </a:solidFill>
+                <a:latin typeface="Calibri"/>
+              </a:rPr>
+              <a:t>• Human-in-the-loop validation is mandatory before acceptance, measuring human–model agreement.</a:t>
+            </a:r>
+          </a:p>
+        </p:txBody>
+      </p:sp>
+      <p:sp>
+        <p:nvSpPr>
+          <p:cNvPr id="5" name="TextBox 4"/>
+          <p:cNvSpPr txBox="1"/>
+          <p:nvPr/>
+        </p:nvSpPr>
+        <p:spPr>
+          <a:xfrm>
+            <a:off x="640080" y="6400800"/>
+            <a:ext cx="8686800" cy="320040"/>
+          </a:xfrm>
+          <a:prstGeom prst="rect">
+            <a:avLst/>
+          </a:prstGeom>
+          <a:noFill/>
+        </p:spPr>
+        <p:txBody>
+          <a:bodyPr wrap="square">
+            <a:spAutoFit/>
+          </a:bodyPr>
+          <a:lstStyle/>
+          <a:p>
+            <a:pPr algn="r" rtl="1"/>
+            <a:r>
+              <a:rPr sz="1000" b="0">
+                <a:solidFill>
+                  <a:srgbClr val="666666"/>
+                </a:solidFill>
+                <a:latin typeface="Arial"/>
+              </a:rPr>
+              <a:t>Module 02 — Data &amp; AI Engineering Track  |  الوحدة الثانية</a:t>
+            </a:r>
+          </a:p>
+        </p:txBody>
+      </p:sp>
+      <p:sp>
+        <p:nvSpPr>
+          <p:cNvPr id="6" name="TextBox 5"/>
+          <p:cNvSpPr txBox="1"/>
+          <p:nvPr/>
+        </p:nvSpPr>
+        <p:spPr>
+          <a:xfrm>
+            <a:off x="9601200" y="6400800"/>
+            <a:ext cx="1920240" cy="320040"/>
+          </a:xfrm>
+          <a:prstGeom prst="rect">
+            <a:avLst/>
+          </a:prstGeom>
+          <a:noFill/>
+        </p:spPr>
+        <p:txBody>
+          <a:bodyPr wrap="square">
+            <a:spAutoFit/>
+          </a:bodyPr>
+          <a:lstStyle/>
+          <a:p>
+            <a:pPr algn="l" rtl="0"/>
+            <a:r>
+              <a:rPr sz="1000" b="0">
+                <a:solidFill>
+                  <a:srgbClr val="666666"/>
+                </a:solidFill>
+                <a:latin typeface="Calibri"/>
+              </a:rPr>
+              <a:t>V10  •  5/11</a:t>
+            </a:r>
+          </a:p>
+        </p:txBody>
+      </p:sp>
+      <p:sp>
+        <p:nvSpPr>
+          <p:cNvPr id="7" name="TextBox 6"/>
+          <p:cNvSpPr txBox="1"/>
+          <p:nvPr/>
+        </p:nvSpPr>
+        <p:spPr>
+          <a:xfrm>
+            <a:off x="640080" y="6400800"/>
+            <a:ext cx="8686800" cy="320040"/>
+          </a:xfrm>
+          <a:prstGeom prst="rect">
+            <a:avLst/>
+          </a:prstGeom>
+          <a:noFill/>
+        </p:spPr>
+        <p:txBody>
+          <a:bodyPr wrap="square">
+            <a:spAutoFit/>
+          </a:bodyPr>
+          <a:lstStyle/>
+          <a:p>
+            <a:pPr algn="r" rtl="1"/>
+            <a:r>
+              <a:rPr sz="1000" b="0">
+                <a:solidFill>
+                  <a:srgbClr val="666666"/>
+                </a:solidFill>
+                <a:latin typeface="Arial"/>
+              </a:rPr>
+              <a:t>Module 02 — Data &amp; AI Engineering Track  |  الوحدة الثانية</a:t>
+            </a:r>
+          </a:p>
+        </p:txBody>
+      </p:sp>
+      <p:sp>
+        <p:nvSpPr>
+          <p:cNvPr id="8" name="TextBox 7"/>
+          <p:cNvSpPr txBox="1"/>
+          <p:nvPr/>
+        </p:nvSpPr>
+        <p:spPr>
+          <a:xfrm>
+            <a:off x="9601200" y="6400800"/>
+            <a:ext cx="1920240" cy="320040"/>
+          </a:xfrm>
+          <a:prstGeom prst="rect">
+            <a:avLst/>
+          </a:prstGeom>
+          <a:noFill/>
+        </p:spPr>
+        <p:txBody>
+          <a:bodyPr wrap="square">
+            <a:spAutoFit/>
+          </a:bodyPr>
+          <a:lstStyle/>
+          <a:p>
+            <a:pPr algn="l" rtl="0"/>
+            <a:r>
+              <a:rPr sz="1000" b="0">
+                <a:solidFill>
+                  <a:srgbClr val="666666"/>
+                </a:solidFill>
+                <a:latin typeface="Calibri"/>
+              </a:rPr>
+              <a:t>10_  •  5/9</a:t>
+            </a:r>
+          </a:p>
+        </p:txBody>
+      </p:sp>
+      <p:sp>
+        <p:nvSpPr>
+          <p:cNvPr id="9" name="TextBox 8"/>
+          <p:cNvSpPr txBox="1"/>
+          <p:nvPr/>
+        </p:nvSpPr>
+        <p:spPr>
+          <a:xfrm>
+            <a:off x="640080" y="6400800"/>
+            <a:ext cx="8686800" cy="320040"/>
+          </a:xfrm>
+          <a:prstGeom prst="rect">
+            <a:avLst/>
+          </a:prstGeom>
+          <a:noFill/>
+        </p:spPr>
+        <p:txBody>
+          <a:bodyPr wrap="square">
+            <a:spAutoFit/>
+          </a:bodyPr>
+          <a:lstStyle/>
+          <a:p>
+            <a:pPr algn="r" rtl="1"/>
+            <a:r>
+              <a:rPr sz="1000" b="0">
+                <a:solidFill>
+                  <a:srgbClr val="666666"/>
+                </a:solidFill>
+                <a:latin typeface="Arial"/>
+              </a:rPr>
+              <a:t>Module 02 — Data &amp; AI Engineering Track  |  الوحدة الثانية</a:t>
+            </a:r>
+          </a:p>
+        </p:txBody>
+      </p:sp>
+      <p:sp>
+        <p:nvSpPr>
+          <p:cNvPr id="10" name="TextBox 9"/>
+          <p:cNvSpPr txBox="1"/>
+          <p:nvPr/>
+        </p:nvSpPr>
+        <p:spPr>
+          <a:xfrm>
+            <a:off x="9601200" y="6400800"/>
+            <a:ext cx="1920240" cy="320040"/>
+          </a:xfrm>
+          <a:prstGeom prst="rect">
+            <a:avLst/>
+          </a:prstGeom>
+          <a:noFill/>
+        </p:spPr>
+        <p:txBody>
+          <a:bodyPr wrap="square">
+            <a:spAutoFit/>
+          </a:bodyPr>
+          <a:lstStyle/>
+          <a:p>
+            <a:pPr algn="l" rtl="0"/>
+            <a:r>
+              <a:rPr sz="1000" b="0">
+                <a:solidFill>
+                  <a:srgbClr val="666666"/>
+                </a:solidFill>
+                <a:latin typeface="Calibri"/>
+              </a:rPr>
+              <a:t>10_  •  5/9</a:t>
             </a:r>
           </a:p>
         </p:txBody>
@@ -4469,22 +5124,57 @@
       <p:grpSpPr/>
       <p:sp>
         <p:nvSpPr>
-          <p:cNvPr id="2" name="Rectangle 1"/>
+          <p:cNvPr id="2" name="TextBox 1"/>
+          <p:cNvSpPr txBox="1"/>
+          <p:nvPr/>
+        </p:nvSpPr>
+        <p:spPr>
+          <a:xfrm>
+            <a:off x="640080" y="137160"/>
+            <a:ext cx="10972800" cy="640080"/>
+          </a:xfrm>
+          <a:prstGeom prst="rect">
+            <a:avLst/>
+          </a:prstGeom>
+          <a:noFill/>
+        </p:spPr>
+        <p:txBody>
+          <a:bodyPr wrap="none">
+            <a:spAutoFit/>
+          </a:bodyPr>
+          <a:lstStyle/>
+          <a:p>
+            <a:pPr algn="r" rtl="1"/>
+            <a:r>
+              <a:rPr sz="3000" b="1">
+                <a:solidFill>
+                  <a:srgbClr val="1F3B5C"/>
+                </a:solidFill>
+                <a:latin typeface="Arial"/>
+              </a:rPr>
+              <a:t>سير عمل التصنيف بمساعدة LLM / LLM-assisted Labeling Workflow</a:t>
+            </a:r>
+          </a:p>
+        </p:txBody>
+      </p:sp>
+      <p:sp>
+        <p:nvSpPr>
+          <p:cNvPr id="3" name="Rounded Rectangle 2"/>
           <p:cNvSpPr/>
           <p:nvPr/>
         </p:nvSpPr>
         <p:spPr>
           <a:xfrm>
-            <a:off x="0" y="0"/>
-            <a:ext cx="12191695" cy="1005840"/>
-          </a:xfrm>
-          <a:prstGeom prst="rect">
+            <a:off x="640080" y="2103120"/>
+            <a:ext cx="1965960" cy="1280160"/>
+          </a:xfrm>
+          <a:prstGeom prst="roundRect">
             <a:avLst/>
           </a:prstGeom>
           <a:solidFill>
-            <a:srgbClr val="FFFFFF"/>
+            <a:srgbClr val="EDEDED"/>
           </a:solidFill>
-          <a:ln w="25400">
+          <a:ln w="12700">
             <a:solidFill>
               <a:srgbClr val="1F4E79"/>
             </a:solidFill>
@@ -4506,6 +5196,71 @@
           </a:fontRef>
         </p:style>
         <p:txBody>
+          <a:bodyPr rtlCol="0" anchor="ctr" wrap="square"/>
+          <a:lstStyle/>
+          <a:p>
+            <a:pPr algn="ctr" rtl="1"/>
+            <a:r>
+              <a:rPr sz="1500" b="1">
+                <a:solidFill>
+                  <a:srgbClr val="333333"/>
+                </a:solidFill>
+                <a:latin typeface="Arial"/>
+              </a:rPr>
+              <a:t>بيانات خام</a:t>
+            </a:r>
+          </a:p>
+          <a:p>
+            <a:pPr algn="ctr" rtl="0"/>
+            <a:r>
+              <a:rPr sz="1200">
+                <a:solidFill>
+                  <a:srgbClr val="666666"/>
+                </a:solidFill>
+                <a:latin typeface="Calibri"/>
+              </a:rPr>
+              <a:t>Raw data</a:t>
+            </a:r>
+          </a:p>
+        </p:txBody>
+      </p:sp>
+      <p:sp>
+        <p:nvSpPr>
+          <p:cNvPr id="4" name="Left Arrow 3"/>
+          <p:cNvSpPr/>
+          <p:nvPr/>
+        </p:nvSpPr>
+        <p:spPr>
+          <a:xfrm>
+            <a:off x="2624328" y="2606040"/>
+            <a:ext cx="274320" cy="274320"/>
+          </a:xfrm>
+          <a:prstGeom prst="leftArrow">
+            <a:avLst/>
+          </a:prstGeom>
+          <a:solidFill>
+            <a:srgbClr val="1F4E79"/>
+          </a:solidFill>
+          <a:ln>
+            <a:noFill/>
+          </a:ln>
+          <a:effectLst/>
+        </p:spPr>
+        <p:style>
+          <a:lnRef idx="1">
+            <a:schemeClr val="accent1"/>
+          </a:lnRef>
+          <a:fillRef idx="3">
+            <a:schemeClr val="accent1"/>
+          </a:fillRef>
+          <a:effectRef idx="2">
+            <a:schemeClr val="accent1"/>
+          </a:effectRef>
+          <a:fontRef idx="minor">
+            <a:schemeClr val="lt1"/>
+          </a:fontRef>
+        </p:style>
+        <p:txBody>
           <a:bodyPr rtlCol="0" anchor="ctr"/>
           <a:lstStyle/>
           <a:p>
@@ -4515,14 +5270,481 @@
       </p:sp>
       <p:sp>
         <p:nvSpPr>
-          <p:cNvPr id="3" name="TextBox 2"/>
+          <p:cNvPr id="5" name="Rounded Rectangle 4"/>
+          <p:cNvSpPr/>
+          <p:nvPr/>
+        </p:nvSpPr>
+        <p:spPr>
+          <a:xfrm>
+            <a:off x="2926080" y="2103120"/>
+            <a:ext cx="1965960" cy="1280160"/>
+          </a:xfrm>
+          <a:prstGeom prst="roundRect">
+            <a:avLst/>
+          </a:prstGeom>
+          <a:solidFill>
+            <a:srgbClr val="DCE6F1"/>
+          </a:solidFill>
+          <a:ln w="12700">
+            <a:solidFill>
+              <a:srgbClr val="1F4E79"/>
+            </a:solidFill>
+          </a:ln>
+          <a:effectLst/>
+        </p:spPr>
+        <p:style>
+          <a:lnRef idx="1">
+            <a:schemeClr val="accent1"/>
+          </a:lnRef>
+          <a:fillRef idx="3">
+            <a:schemeClr val="accent1"/>
+          </a:fillRef>
+          <a:effectRef idx="2">
+            <a:schemeClr val="accent1"/>
+          </a:effectRef>
+          <a:fontRef idx="minor">
+            <a:schemeClr val="lt1"/>
+          </a:fontRef>
+        </p:style>
+        <p:txBody>
+          <a:bodyPr rtlCol="0" anchor="ctr" wrap="square"/>
+          <a:lstStyle/>
+          <a:p>
+            <a:pPr algn="ctr" rtl="1"/>
+            <a:r>
+              <a:rPr sz="1500" b="1">
+                <a:solidFill>
+                  <a:srgbClr val="333333"/>
+                </a:solidFill>
+                <a:latin typeface="Arial"/>
+              </a:rPr>
+              <a:t>تسمية مبدئية بالـ LLM</a:t>
+            </a:r>
+          </a:p>
+          <a:p>
+            <a:pPr algn="ctr" rtl="0"/>
+            <a:r>
+              <a:rPr sz="1200">
+                <a:solidFill>
+                  <a:srgbClr val="666666"/>
+                </a:solidFill>
+                <a:latin typeface="Calibri"/>
+              </a:rPr>
+              <a:t>LLM pre-labeling</a:t>
+            </a:r>
+          </a:p>
+        </p:txBody>
+      </p:sp>
+      <p:sp>
+        <p:nvSpPr>
+          <p:cNvPr id="6" name="Left Arrow 5"/>
+          <p:cNvSpPr/>
+          <p:nvPr/>
+        </p:nvSpPr>
+        <p:spPr>
+          <a:xfrm>
+            <a:off x="4910328" y="2606040"/>
+            <a:ext cx="274320" cy="274320"/>
+          </a:xfrm>
+          <a:prstGeom prst="leftArrow">
+            <a:avLst/>
+          </a:prstGeom>
+          <a:solidFill>
+            <a:srgbClr val="1F4E79"/>
+          </a:solidFill>
+          <a:ln>
+            <a:noFill/>
+          </a:ln>
+          <a:effectLst/>
+        </p:spPr>
+        <p:style>
+          <a:lnRef idx="1">
+            <a:schemeClr val="accent1"/>
+          </a:lnRef>
+          <a:fillRef idx="3">
+            <a:schemeClr val="accent1"/>
+          </a:fillRef>
+          <a:effectRef idx="2">
+            <a:schemeClr val="accent1"/>
+          </a:effectRef>
+          <a:fontRef idx="minor">
+            <a:schemeClr val="lt1"/>
+          </a:fontRef>
+        </p:style>
+        <p:txBody>
+          <a:bodyPr rtlCol="0" anchor="ctr"/>
+          <a:lstStyle/>
+          <a:p>
+            <a:pPr algn="ctr"/>
+          </a:p>
+        </p:txBody>
+      </p:sp>
+      <p:sp>
+        <p:nvSpPr>
+          <p:cNvPr id="7" name="Rounded Rectangle 6"/>
+          <p:cNvSpPr/>
+          <p:nvPr/>
+        </p:nvSpPr>
+        <p:spPr>
+          <a:xfrm>
+            <a:off x="5212080" y="2103120"/>
+            <a:ext cx="1965960" cy="1280160"/>
+          </a:xfrm>
+          <a:prstGeom prst="roundRect">
+            <a:avLst/>
+          </a:prstGeom>
+          <a:solidFill>
+            <a:srgbClr val="E2EFDA"/>
+          </a:solidFill>
+          <a:ln w="12700">
+            <a:solidFill>
+              <a:srgbClr val="1F4E79"/>
+            </a:solidFill>
+          </a:ln>
+          <a:effectLst/>
+        </p:spPr>
+        <p:style>
+          <a:lnRef idx="1">
+            <a:schemeClr val="accent1"/>
+          </a:lnRef>
+          <a:fillRef idx="3">
+            <a:schemeClr val="accent1"/>
+          </a:fillRef>
+          <a:effectRef idx="2">
+            <a:schemeClr val="accent1"/>
+          </a:effectRef>
+          <a:fontRef idx="minor">
+            <a:schemeClr val="lt1"/>
+          </a:fontRef>
+        </p:style>
+        <p:txBody>
+          <a:bodyPr rtlCol="0" anchor="ctr" wrap="square"/>
+          <a:lstStyle/>
+          <a:p>
+            <a:pPr algn="ctr" rtl="1"/>
+            <a:r>
+              <a:rPr sz="1500" b="1">
+                <a:solidFill>
+                  <a:srgbClr val="333333"/>
+                </a:solidFill>
+                <a:latin typeface="Arial"/>
+              </a:rPr>
+              <a:t>مراجعة وتصحيح بشري</a:t>
+            </a:r>
+          </a:p>
+          <a:p>
+            <a:pPr algn="ctr" rtl="0"/>
+            <a:r>
+              <a:rPr sz="1200">
+                <a:solidFill>
+                  <a:srgbClr val="666666"/>
+                </a:solidFill>
+                <a:latin typeface="Calibri"/>
+              </a:rPr>
+              <a:t>Human review (HITL)</a:t>
+            </a:r>
+          </a:p>
+        </p:txBody>
+      </p:sp>
+      <p:sp>
+        <p:nvSpPr>
+          <p:cNvPr id="8" name="Left Arrow 7"/>
+          <p:cNvSpPr/>
+          <p:nvPr/>
+        </p:nvSpPr>
+        <p:spPr>
+          <a:xfrm>
+            <a:off x="7196328" y="2606040"/>
+            <a:ext cx="274320" cy="274320"/>
+          </a:xfrm>
+          <a:prstGeom prst="leftArrow">
+            <a:avLst/>
+          </a:prstGeom>
+          <a:solidFill>
+            <a:srgbClr val="1F4E79"/>
+          </a:solidFill>
+          <a:ln>
+            <a:noFill/>
+          </a:ln>
+          <a:effectLst/>
+        </p:spPr>
+        <p:style>
+          <a:lnRef idx="1">
+            <a:schemeClr val="accent1"/>
+          </a:lnRef>
+          <a:fillRef idx="3">
+            <a:schemeClr val="accent1"/>
+          </a:fillRef>
+          <a:effectRef idx="2">
+            <a:schemeClr val="accent1"/>
+          </a:effectRef>
+          <a:fontRef idx="minor">
+            <a:schemeClr val="lt1"/>
+          </a:fontRef>
+        </p:style>
+        <p:txBody>
+          <a:bodyPr rtlCol="0" anchor="ctr"/>
+          <a:lstStyle/>
+          <a:p>
+            <a:pPr algn="ctr"/>
+          </a:p>
+        </p:txBody>
+      </p:sp>
+      <p:sp>
+        <p:nvSpPr>
+          <p:cNvPr id="9" name="Rounded Rectangle 8"/>
+          <p:cNvSpPr/>
+          <p:nvPr/>
+        </p:nvSpPr>
+        <p:spPr>
+          <a:xfrm>
+            <a:off x="7498080" y="2103120"/>
+            <a:ext cx="1965960" cy="1280160"/>
+          </a:xfrm>
+          <a:prstGeom prst="roundRect">
+            <a:avLst/>
+          </a:prstGeom>
+          <a:solidFill>
+            <a:srgbClr val="FDE9D9"/>
+          </a:solidFill>
+          <a:ln w="12700">
+            <a:solidFill>
+              <a:srgbClr val="1F4E79"/>
+            </a:solidFill>
+          </a:ln>
+          <a:effectLst/>
+        </p:spPr>
+        <p:style>
+          <a:lnRef idx="1">
+            <a:schemeClr val="accent1"/>
+          </a:lnRef>
+          <a:fillRef idx="3">
+            <a:schemeClr val="accent1"/>
+          </a:fillRef>
+          <a:effectRef idx="2">
+            <a:schemeClr val="accent1"/>
+          </a:effectRef>
+          <a:fontRef idx="minor">
+            <a:schemeClr val="lt1"/>
+          </a:fontRef>
+        </p:style>
+        <p:txBody>
+          <a:bodyPr rtlCol="0" anchor="ctr" wrap="square"/>
+          <a:lstStyle/>
+          <a:p>
+            <a:pPr algn="ctr" rtl="1"/>
+            <a:r>
+              <a:rPr sz="1500" b="1">
+                <a:solidFill>
+                  <a:srgbClr val="333333"/>
+                </a:solidFill>
+                <a:latin typeface="Arial"/>
+              </a:rPr>
+              <a:t>تسميات معتمدة</a:t>
+            </a:r>
+          </a:p>
+          <a:p>
+            <a:pPr algn="ctr" rtl="0"/>
+            <a:r>
+              <a:rPr sz="1200">
+                <a:solidFill>
+                  <a:srgbClr val="666666"/>
+                </a:solidFill>
+                <a:latin typeface="Calibri"/>
+              </a:rPr>
+              <a:t>Approved labels</a:t>
+            </a:r>
+          </a:p>
+        </p:txBody>
+      </p:sp>
+      <p:sp>
+        <p:nvSpPr>
+          <p:cNvPr id="10" name="Left Arrow 9"/>
+          <p:cNvSpPr/>
+          <p:nvPr/>
+        </p:nvSpPr>
+        <p:spPr>
+          <a:xfrm>
+            <a:off x="9482328" y="2606040"/>
+            <a:ext cx="274320" cy="274320"/>
+          </a:xfrm>
+          <a:prstGeom prst="leftArrow">
+            <a:avLst/>
+          </a:prstGeom>
+          <a:solidFill>
+            <a:srgbClr val="1F4E79"/>
+          </a:solidFill>
+          <a:ln>
+            <a:noFill/>
+          </a:ln>
+          <a:effectLst/>
+        </p:spPr>
+        <p:style>
+          <a:lnRef idx="1">
+            <a:schemeClr val="accent1"/>
+          </a:lnRef>
+          <a:fillRef idx="3">
+            <a:schemeClr val="accent1"/>
+          </a:fillRef>
+          <a:effectRef idx="2">
+            <a:schemeClr val="accent1"/>
+          </a:effectRef>
+          <a:fontRef idx="minor">
+            <a:schemeClr val="lt1"/>
+          </a:fontRef>
+        </p:style>
+        <p:txBody>
+          <a:bodyPr rtlCol="0" anchor="ctr"/>
+          <a:lstStyle/>
+          <a:p>
+            <a:pPr algn="ctr"/>
+          </a:p>
+        </p:txBody>
+      </p:sp>
+      <p:sp>
+        <p:nvSpPr>
+          <p:cNvPr id="11" name="Rounded Rectangle 10"/>
+          <p:cNvSpPr/>
+          <p:nvPr/>
+        </p:nvSpPr>
+        <p:spPr>
+          <a:xfrm>
+            <a:off x="9784080" y="2103120"/>
+            <a:ext cx="1965960" cy="1280160"/>
+          </a:xfrm>
+          <a:prstGeom prst="roundRect">
+            <a:avLst/>
+          </a:prstGeom>
+          <a:solidFill>
+            <a:srgbClr val="EDEDED"/>
+          </a:solidFill>
+          <a:ln w="12700">
+            <a:solidFill>
+              <a:srgbClr val="1F4E79"/>
+            </a:solidFill>
+          </a:ln>
+          <a:effectLst/>
+        </p:spPr>
+        <p:style>
+          <a:lnRef idx="1">
+            <a:schemeClr val="accent1"/>
+          </a:lnRef>
+          <a:fillRef idx="3">
+            <a:schemeClr val="accent1"/>
+          </a:fillRef>
+          <a:effectRef idx="2">
+            <a:schemeClr val="accent1"/>
+          </a:effectRef>
+          <a:fontRef idx="minor">
+            <a:schemeClr val="lt1"/>
+          </a:fontRef>
+        </p:style>
+        <p:txBody>
+          <a:bodyPr rtlCol="0" anchor="ctr" wrap="square"/>
+          <a:lstStyle/>
+          <a:p>
+            <a:pPr algn="ctr" rtl="1"/>
+            <a:r>
+              <a:rPr sz="1500" b="1">
+                <a:solidFill>
+                  <a:srgbClr val="333333"/>
+                </a:solidFill>
+                <a:latin typeface="Arial"/>
+              </a:rPr>
+              <a:t>تدريب النموذج</a:t>
+            </a:r>
+          </a:p>
+          <a:p>
+            <a:pPr algn="ctr" rtl="0"/>
+            <a:r>
+              <a:rPr sz="1200">
+                <a:solidFill>
+                  <a:srgbClr val="666666"/>
+                </a:solidFill>
+                <a:latin typeface="Calibri"/>
+              </a:rPr>
+              <a:t>Model training</a:t>
+            </a:r>
+          </a:p>
+        </p:txBody>
+      </p:sp>
+      <p:sp>
+        <p:nvSpPr>
+          <p:cNvPr id="12" name="Rounded Rectangle 11"/>
+          <p:cNvSpPr/>
+          <p:nvPr/>
+        </p:nvSpPr>
+        <p:spPr>
+          <a:xfrm>
+            <a:off x="2743200" y="4023360"/>
+            <a:ext cx="6766560" cy="731520"/>
+          </a:xfrm>
+          <a:prstGeom prst="roundRect">
+            <a:avLst/>
+          </a:prstGeom>
+          <a:solidFill>
+            <a:srgbClr val="EDEDED"/>
+          </a:solidFill>
+          <a:ln w="12700">
+            <a:solidFill>
+              <a:srgbClr val="1F4E79"/>
+            </a:solidFill>
+          </a:ln>
+          <a:effectLst/>
+        </p:spPr>
+        <p:style>
+          <a:lnRef idx="1">
+            <a:schemeClr val="accent1"/>
+          </a:lnRef>
+          <a:fillRef idx="3">
+            <a:schemeClr val="accent1"/>
+          </a:fillRef>
+          <a:effectRef idx="2">
+            <a:schemeClr val="accent1"/>
+          </a:effectRef>
+          <a:fontRef idx="minor">
+            <a:schemeClr val="lt1"/>
+          </a:fontRef>
+        </p:style>
+        <p:txBody>
+          <a:bodyPr rtlCol="0" anchor="ctr" wrap="square"/>
+          <a:lstStyle/>
+          <a:p>
+            <a:pPr algn="ctr" rtl="1"/>
+            <a:r>
+              <a:rPr sz="1300" b="1">
+                <a:solidFill>
+                  <a:srgbClr val="333333"/>
+                </a:solidFill>
+                <a:latin typeface="Arial"/>
+              </a:rPr>
+              <a:t>حلقة تغذية راجعة: تصحيحات البشر تُحسِّن موجِّهات الـ LLM</a:t>
+            </a:r>
+          </a:p>
+          <a:p>
+            <a:pPr algn="ctr" rtl="0"/>
+            <a:r>
+              <a:rPr sz="1100">
+                <a:solidFill>
+                  <a:srgbClr val="666666"/>
+                </a:solidFill>
+                <a:latin typeface="Calibri"/>
+              </a:rPr>
+              <a:t>Feedback loop: human corrections improve LLM prompts</a:t>
+            </a:r>
+          </a:p>
+        </p:txBody>
+      </p:sp>
+      <p:sp>
+        <p:nvSpPr>
+          <p:cNvPr id="13" name="TextBox 12"/>
           <p:cNvSpPr txBox="1"/>
           <p:nvPr/>
         </p:nvSpPr>
         <p:spPr>
           <a:xfrm>
-            <a:off x="640080" y="182880"/>
-            <a:ext cx="10972800" cy="640080"/>
+            <a:off x="640080" y="6126480"/>
+            <a:ext cx="10972800" cy="548640"/>
           </a:xfrm>
           <a:prstGeom prst="rect">
             <a:avLst/>
@@ -4537,27 +5759,33 @@
           <a:p>
             <a:pPr algn="r" rtl="1"/>
             <a:r>
-              <a:rPr sz="3200" b="1">
-                <a:solidFill>
-                  <a:srgbClr val="1F3B5C"/>
-                </a:solidFill>
-                <a:latin typeface="Calibri"/>
-              </a:rPr>
-              <a:t>اختبار قصير / Quick Quiz</a:t>
-            </a:r>
-          </a:p>
-        </p:txBody>
-      </p:sp>
-      <p:sp>
-        <p:nvSpPr>
-          <p:cNvPr id="4" name="TextBox 3"/>
+              <a:rPr sz="1400">
+                <a:solidFill>
+                  <a:srgbClr val="666666"/>
+                </a:solidFill>
+                <a:latin typeface="Arial"/>
+              </a:rPr>
+              <a:t>الـ LLM يسرّع التسمية والبشر يضمنون الجودة — أفضل الممارسات الحديثة.</a:t>
+            </a:r>
+          </a:p>
+          <a:p>
+            <a:pPr algn="r" rtl="0"/>
+            <a:r>
+              <a:t>LLM accelerates labeling; humans guarantee quality — modern best practice.</a:t>
+            </a:r>
+          </a:p>
+        </p:txBody>
+      </p:sp>
+      <p:sp>
+        <p:nvSpPr>
+          <p:cNvPr id="14" name="TextBox 13"/>
           <p:cNvSpPr txBox="1"/>
           <p:nvPr/>
         </p:nvSpPr>
         <p:spPr>
           <a:xfrm>
-            <a:off x="640080" y="1280160"/>
-            <a:ext cx="10972800" cy="5212080"/>
+            <a:off x="640080" y="6400800"/>
+            <a:ext cx="8686800" cy="320040"/>
           </a:xfrm>
           <a:prstGeom prst="rect">
             <a:avLst/>
@@ -4570,67 +5798,120 @@
           </a:bodyPr>
           <a:lstStyle/>
           <a:p>
-            <a:pPr algn="r" rtl="1">
-              <a:spcAft>
-                <a:spcPts val="1000"/>
-              </a:spcAft>
-            </a:pPr>
-            <a:r>
-              <a:rPr sz="2000">
-                <a:solidFill>
-                  <a:srgbClr val="333333"/>
+            <a:pPr algn="r" rtl="1"/>
+            <a:r>
+              <a:rPr sz="1000" b="0">
+                <a:solidFill>
+                  <a:srgbClr val="666666"/>
+                </a:solidFill>
+                <a:latin typeface="Arial"/>
+              </a:rPr>
+              <a:t>Module 02 — Data &amp; AI Engineering Track  |  الوحدة الثانية</a:t>
+            </a:r>
+          </a:p>
+        </p:txBody>
+      </p:sp>
+      <p:sp>
+        <p:nvSpPr>
+          <p:cNvPr id="15" name="TextBox 14"/>
+          <p:cNvSpPr txBox="1"/>
+          <p:nvPr/>
+        </p:nvSpPr>
+        <p:spPr>
+          <a:xfrm>
+            <a:off x="9601200" y="6400800"/>
+            <a:ext cx="1920240" cy="320040"/>
+          </a:xfrm>
+          <a:prstGeom prst="rect">
+            <a:avLst/>
+          </a:prstGeom>
+          <a:noFill/>
+        </p:spPr>
+        <p:txBody>
+          <a:bodyPr wrap="square">
+            <a:spAutoFit/>
+          </a:bodyPr>
+          <a:lstStyle/>
+          <a:p>
+            <a:pPr algn="l" rtl="0"/>
+            <a:r>
+              <a:rPr sz="1000" b="0">
+                <a:solidFill>
+                  <a:srgbClr val="666666"/>
                 </a:solidFill>
                 <a:latin typeface="Calibri"/>
               </a:rPr>
-              <a:t>• 1. لماذا لا نعتمد تصنيفات LLM مباشرة دون مراجعة؟</a:t>
-            </a:r>
-          </a:p>
-          <a:p>
-            <a:pPr algn="r" rtl="0">
-              <a:spcAft>
-                <a:spcPts val="1000"/>
-              </a:spcAft>
-            </a:pPr>
-            <a:r>
-              <a:rPr sz="2000">
+              <a:t>10_  •  6/9</a:t>
+            </a:r>
+          </a:p>
+        </p:txBody>
+      </p:sp>
+      <p:sp>
+        <p:nvSpPr>
+          <p:cNvPr id="16" name="TextBox 15"/>
+          <p:cNvSpPr txBox="1"/>
+          <p:nvPr/>
+        </p:nvSpPr>
+        <p:spPr>
+          <a:xfrm>
+            <a:off x="640080" y="6400800"/>
+            <a:ext cx="8686800" cy="320040"/>
+          </a:xfrm>
+          <a:prstGeom prst="rect">
+            <a:avLst/>
+          </a:prstGeom>
+          <a:noFill/>
+        </p:spPr>
+        <p:txBody>
+          <a:bodyPr wrap="square">
+            <a:spAutoFit/>
+          </a:bodyPr>
+          <a:lstStyle/>
+          <a:p>
+            <a:pPr algn="r" rtl="1"/>
+            <a:r>
+              <a:rPr sz="1000" b="0">
                 <a:solidFill>
                   <a:srgbClr val="666666"/>
                 </a:solidFill>
+                <a:latin typeface="Arial"/>
+              </a:rPr>
+              <a:t>Module 02 — Data &amp; AI Engineering Track  |  الوحدة الثانية</a:t>
+            </a:r>
+          </a:p>
+        </p:txBody>
+      </p:sp>
+      <p:sp>
+        <p:nvSpPr>
+          <p:cNvPr id="17" name="TextBox 16"/>
+          <p:cNvSpPr txBox="1"/>
+          <p:nvPr/>
+        </p:nvSpPr>
+        <p:spPr>
+          <a:xfrm>
+            <a:off x="9601200" y="6400800"/>
+            <a:ext cx="1920240" cy="320040"/>
+          </a:xfrm>
+          <a:prstGeom prst="rect">
+            <a:avLst/>
+          </a:prstGeom>
+          <a:noFill/>
+        </p:spPr>
+        <p:txBody>
+          <a:bodyPr wrap="square">
+            <a:spAutoFit/>
+          </a:bodyPr>
+          <a:lstStyle/>
+          <a:p>
+            <a:pPr algn="l" rtl="0"/>
+            <a:r>
+              <a:rPr sz="1000" b="0">
+                <a:solidFill>
+                  <a:srgbClr val="666666"/>
+                </a:solidFill>
                 <a:latin typeface="Calibri"/>
               </a:rPr>
-              <a:t>   Why not accept LLM labels directly without review?</a:t>
-            </a:r>
-          </a:p>
-          <a:p>
-            <a:pPr algn="r" rtl="1">
-              <a:spcAft>
-                <a:spcPts val="1000"/>
-              </a:spcAft>
-            </a:pPr>
-            <a:r>
-              <a:rPr sz="2000">
-                <a:solidFill>
-                  <a:srgbClr val="333333"/>
-                </a:solidFill>
-                <a:latin typeface="Calibri"/>
-              </a:rPr>
-              <a:t>• 2. أي أداة تناسب مشاريع الرؤية الحاسوبية؟</a:t>
-            </a:r>
-          </a:p>
-          <a:p>
-            <a:pPr algn="r" rtl="0">
-              <a:spcAft>
-                <a:spcPts val="1000"/>
-              </a:spcAft>
-            </a:pPr>
-            <a:r>
-              <a:rPr sz="2000">
-                <a:solidFill>
-                  <a:srgbClr val="666666"/>
-                </a:solidFill>
-                <a:latin typeface="Calibri"/>
-              </a:rPr>
-              <a:t>   Which tool fits computer-vision projects?</a:t>
+              <a:t>10_  •  6/9</a:t>
             </a:r>
           </a:p>
         </p:txBody>
@@ -4735,9 +6016,9 @@
                 <a:solidFill>
                   <a:srgbClr val="1F3B5C"/>
                 </a:solidFill>
-                <a:latin typeface="Calibri"/>
-              </a:rPr>
-              <a:t>للاستزادة / Further Reading</a:t>
+                <a:latin typeface="Arial"/>
+              </a:rPr>
+              <a:t>اختبار قصير / Quick Quiz</a:t>
             </a:r>
           </a:p>
         </p:txBody>
@@ -4765,6 +6046,9 @@
           <a:lstStyle/>
           <a:p>
             <a:pPr algn="r" rtl="1">
+              <a:spcBef>
+                <a:spcPts val="200"/>
+              </a:spcBef>
               <a:spcAft>
                 <a:spcPts val="1000"/>
               </a:spcAft>
@@ -4774,29 +6058,35 @@
                 <a:solidFill>
                   <a:srgbClr val="333333"/>
                 </a:solidFill>
-                <a:latin typeface="Calibri"/>
-              </a:rPr>
-              <a:t>• توثيق Label Studio.</a:t>
-            </a:r>
-          </a:p>
-          <a:p>
-            <a:pPr algn="r" rtl="0">
+                <a:latin typeface="Arial"/>
+              </a:rPr>
+              <a:t>• 1. لماذا لا نعتمد تصنيفات LLM مباشرة دون مراجعة؟</a:t>
+            </a:r>
+          </a:p>
+          <a:p>
+            <a:pPr algn="l" rtl="0">
+              <a:spcBef>
+                <a:spcPts val="200"/>
+              </a:spcBef>
               <a:spcAft>
                 <a:spcPts val="1000"/>
               </a:spcAft>
             </a:pPr>
             <a:r>
-              <a:rPr sz="2000">
+              <a:rPr sz="1700">
                 <a:solidFill>
                   <a:srgbClr val="666666"/>
                 </a:solidFill>
                 <a:latin typeface="Calibri"/>
               </a:rPr>
-              <a:t>   Label Studio docs.</a:t>
+              <a:t>• Why not accept LLM labels directly without review?</a:t>
             </a:r>
           </a:p>
           <a:p>
             <a:pPr algn="r" rtl="1">
+              <a:spcBef>
+                <a:spcPts val="200"/>
+              </a:spcBef>
               <a:spcAft>
                 <a:spcPts val="1000"/>
               </a:spcAft>
@@ -4806,25 +6096,238 @@
                 <a:solidFill>
                   <a:srgbClr val="333333"/>
                 </a:solidFill>
-                <a:latin typeface="Calibri"/>
-              </a:rPr>
-              <a:t>• توثيق Roboflow.</a:t>
-            </a:r>
-          </a:p>
-          <a:p>
-            <a:pPr algn="r" rtl="0">
+                <a:latin typeface="Arial"/>
+              </a:rPr>
+              <a:t>• 2. أي أداة تناسب مشاريع الرؤية الحاسوبية؟</a:t>
+            </a:r>
+          </a:p>
+          <a:p>
+            <a:pPr algn="l" rtl="0">
+              <a:spcBef>
+                <a:spcPts val="200"/>
+              </a:spcBef>
               <a:spcAft>
                 <a:spcPts val="1000"/>
               </a:spcAft>
             </a:pPr>
             <a:r>
-              <a:rPr sz="2000">
+              <a:rPr sz="1700">
                 <a:solidFill>
                   <a:srgbClr val="666666"/>
                 </a:solidFill>
                 <a:latin typeface="Calibri"/>
               </a:rPr>
-              <a:t>   Roboflow docs.</a:t>
+              <a:t>• Which tool fits computer-vision projects?</a:t>
+            </a:r>
+          </a:p>
+        </p:txBody>
+      </p:sp>
+      <p:sp>
+        <p:nvSpPr>
+          <p:cNvPr id="5" name="TextBox 4"/>
+          <p:cNvSpPr txBox="1"/>
+          <p:nvPr/>
+        </p:nvSpPr>
+        <p:spPr>
+          <a:xfrm>
+            <a:off x="640080" y="6400800"/>
+            <a:ext cx="8686800" cy="320040"/>
+          </a:xfrm>
+          <a:prstGeom prst="rect">
+            <a:avLst/>
+          </a:prstGeom>
+          <a:noFill/>
+        </p:spPr>
+        <p:txBody>
+          <a:bodyPr wrap="square">
+            <a:spAutoFit/>
+          </a:bodyPr>
+          <a:lstStyle/>
+          <a:p>
+            <a:pPr algn="r" rtl="1"/>
+            <a:r>
+              <a:rPr sz="1000" b="0">
+                <a:solidFill>
+                  <a:srgbClr val="666666"/>
+                </a:solidFill>
+                <a:latin typeface="Arial"/>
+              </a:rPr>
+              <a:t>Module 02 — Data &amp; AI Engineering Track  |  الوحدة الثانية</a:t>
+            </a:r>
+          </a:p>
+        </p:txBody>
+      </p:sp>
+      <p:sp>
+        <p:nvSpPr>
+          <p:cNvPr id="6" name="TextBox 5"/>
+          <p:cNvSpPr txBox="1"/>
+          <p:nvPr/>
+        </p:nvSpPr>
+        <p:spPr>
+          <a:xfrm>
+            <a:off x="9601200" y="6400800"/>
+            <a:ext cx="1920240" cy="320040"/>
+          </a:xfrm>
+          <a:prstGeom prst="rect">
+            <a:avLst/>
+          </a:prstGeom>
+          <a:noFill/>
+        </p:spPr>
+        <p:txBody>
+          <a:bodyPr wrap="square">
+            <a:spAutoFit/>
+          </a:bodyPr>
+          <a:lstStyle/>
+          <a:p>
+            <a:pPr algn="l" rtl="0"/>
+            <a:r>
+              <a:rPr sz="1000" b="0">
+                <a:solidFill>
+                  <a:srgbClr val="666666"/>
+                </a:solidFill>
+                <a:latin typeface="Calibri"/>
+              </a:rPr>
+              <a:t>V10  •  6/11</a:t>
+            </a:r>
+          </a:p>
+        </p:txBody>
+      </p:sp>
+      <p:sp>
+        <p:nvSpPr>
+          <p:cNvPr id="7" name="TextBox 6"/>
+          <p:cNvSpPr txBox="1"/>
+          <p:nvPr/>
+        </p:nvSpPr>
+        <p:spPr>
+          <a:xfrm>
+            <a:off x="640080" y="6400800"/>
+            <a:ext cx="8686800" cy="320040"/>
+          </a:xfrm>
+          <a:prstGeom prst="rect">
+            <a:avLst/>
+          </a:prstGeom>
+          <a:noFill/>
+        </p:spPr>
+        <p:txBody>
+          <a:bodyPr wrap="square">
+            <a:spAutoFit/>
+          </a:bodyPr>
+          <a:lstStyle/>
+          <a:p>
+            <a:pPr algn="r" rtl="1"/>
+            <a:r>
+              <a:rPr sz="1000" b="0">
+                <a:solidFill>
+                  <a:srgbClr val="666666"/>
+                </a:solidFill>
+                <a:latin typeface="Arial"/>
+              </a:rPr>
+              <a:t>Module 02 — Data &amp; AI Engineering Track  |  الوحدة الثانية</a:t>
+            </a:r>
+          </a:p>
+        </p:txBody>
+      </p:sp>
+      <p:sp>
+        <p:nvSpPr>
+          <p:cNvPr id="8" name="TextBox 7"/>
+          <p:cNvSpPr txBox="1"/>
+          <p:nvPr/>
+        </p:nvSpPr>
+        <p:spPr>
+          <a:xfrm>
+            <a:off x="9601200" y="6400800"/>
+            <a:ext cx="1920240" cy="320040"/>
+          </a:xfrm>
+          <a:prstGeom prst="rect">
+            <a:avLst/>
+          </a:prstGeom>
+          <a:noFill/>
+        </p:spPr>
+        <p:txBody>
+          <a:bodyPr wrap="square">
+            <a:spAutoFit/>
+          </a:bodyPr>
+          <a:lstStyle/>
+          <a:p>
+            <a:pPr algn="l" rtl="0"/>
+            <a:r>
+              <a:rPr sz="1000" b="0">
+                <a:solidFill>
+                  <a:srgbClr val="666666"/>
+                </a:solidFill>
+                <a:latin typeface="Calibri"/>
+              </a:rPr>
+              <a:t>10_  •  7/9</a:t>
+            </a:r>
+          </a:p>
+        </p:txBody>
+      </p:sp>
+      <p:sp>
+        <p:nvSpPr>
+          <p:cNvPr id="9" name="TextBox 8"/>
+          <p:cNvSpPr txBox="1"/>
+          <p:nvPr/>
+        </p:nvSpPr>
+        <p:spPr>
+          <a:xfrm>
+            <a:off x="640080" y="6400800"/>
+            <a:ext cx="8686800" cy="320040"/>
+          </a:xfrm>
+          <a:prstGeom prst="rect">
+            <a:avLst/>
+          </a:prstGeom>
+          <a:noFill/>
+        </p:spPr>
+        <p:txBody>
+          <a:bodyPr wrap="square">
+            <a:spAutoFit/>
+          </a:bodyPr>
+          <a:lstStyle/>
+          <a:p>
+            <a:pPr algn="r" rtl="1"/>
+            <a:r>
+              <a:rPr sz="1000" b="0">
+                <a:solidFill>
+                  <a:srgbClr val="666666"/>
+                </a:solidFill>
+                <a:latin typeface="Arial"/>
+              </a:rPr>
+              <a:t>Module 02 — Data &amp; AI Engineering Track  |  الوحدة الثانية</a:t>
+            </a:r>
+          </a:p>
+        </p:txBody>
+      </p:sp>
+      <p:sp>
+        <p:nvSpPr>
+          <p:cNvPr id="10" name="TextBox 9"/>
+          <p:cNvSpPr txBox="1"/>
+          <p:nvPr/>
+        </p:nvSpPr>
+        <p:spPr>
+          <a:xfrm>
+            <a:off x="9601200" y="6400800"/>
+            <a:ext cx="1920240" cy="320040"/>
+          </a:xfrm>
+          <a:prstGeom prst="rect">
+            <a:avLst/>
+          </a:prstGeom>
+          <a:noFill/>
+        </p:spPr>
+        <p:txBody>
+          <a:bodyPr wrap="square">
+            <a:spAutoFit/>
+          </a:bodyPr>
+          <a:lstStyle/>
+          <a:p>
+            <a:pPr algn="l" rtl="0"/>
+            <a:r>
+              <a:rPr sz="1000" b="0">
+                <a:solidFill>
+                  <a:srgbClr val="666666"/>
+                </a:solidFill>
+                <a:latin typeface="Calibri"/>
+              </a:rPr>
+              <a:t>10_  •  7/9</a:t>
             </a:r>
           </a:p>
         </p:txBody>
@@ -4857,57 +6360,22 @@
       <p:grpSpPr/>
       <p:sp>
         <p:nvSpPr>
-          <p:cNvPr id="2" name="TextBox 1"/>
-          <p:cNvSpPr txBox="1"/>
-          <p:nvPr/>
-        </p:nvSpPr>
-        <p:spPr>
-          <a:xfrm>
-            <a:off x="640080" y="137160"/>
-            <a:ext cx="10972800" cy="640080"/>
-          </a:xfrm>
-          <a:prstGeom prst="rect">
-            <a:avLst/>
-          </a:prstGeom>
-          <a:noFill/>
-        </p:spPr>
-        <p:txBody>
-          <a:bodyPr wrap="none">
-            <a:spAutoFit/>
-          </a:bodyPr>
-          <a:lstStyle/>
-          <a:p>
-            <a:pPr algn="r" rtl="1"/>
-            <a:r>
-              <a:rPr sz="3000" b="1">
-                <a:solidFill>
-                  <a:srgbClr val="1F3B5C"/>
-                </a:solidFill>
-                <a:latin typeface="Calibri"/>
-              </a:rPr>
-              <a:t>سير عمل التصنيف بمساعدة LLM / LLM-assisted Labeling Workflow</a:t>
-            </a:r>
-          </a:p>
-        </p:txBody>
-      </p:sp>
-      <p:sp>
-        <p:nvSpPr>
-          <p:cNvPr id="3" name="Rounded Rectangle 2"/>
+          <p:cNvPr id="2" name="Rectangle 1"/>
           <p:cNvSpPr/>
           <p:nvPr/>
         </p:nvSpPr>
         <p:spPr>
           <a:xfrm>
-            <a:off x="640080" y="2103120"/>
-            <a:ext cx="1965960" cy="1280160"/>
-          </a:xfrm>
-          <a:prstGeom prst="roundRect">
+            <a:off x="0" y="0"/>
+            <a:ext cx="12191695" cy="1005840"/>
+          </a:xfrm>
+          <a:prstGeom prst="rect">
             <a:avLst/>
           </a:prstGeom>
           <a:solidFill>
-            <a:srgbClr val="EDEDED"/>
+            <a:srgbClr val="FFFFFF"/>
           </a:solidFill>
-          <a:ln w="12700">
+          <a:ln w="25400">
             <a:solidFill>
               <a:srgbClr val="1F4E79"/>
             </a:solidFill>
@@ -4929,53 +6397,404 @@
           </a:fontRef>
         </p:style>
         <p:txBody>
-          <a:bodyPr rtlCol="0" anchor="ctr" wrap="square"/>
-          <a:lstStyle/>
-          <a:p>
-            <a:pPr algn="ctr" rtl="1"/>
-            <a:r>
-              <a:rPr sz="1500" b="1">
+          <a:bodyPr rtlCol="0" anchor="ctr"/>
+          <a:lstStyle/>
+          <a:p>
+            <a:pPr algn="ctr"/>
+          </a:p>
+        </p:txBody>
+      </p:sp>
+      <p:sp>
+        <p:nvSpPr>
+          <p:cNvPr id="3" name="TextBox 2"/>
+          <p:cNvSpPr txBox="1"/>
+          <p:nvPr/>
+        </p:nvSpPr>
+        <p:spPr>
+          <a:xfrm>
+            <a:off x="640080" y="182880"/>
+            <a:ext cx="10972800" cy="640080"/>
+          </a:xfrm>
+          <a:prstGeom prst="rect">
+            <a:avLst/>
+          </a:prstGeom>
+          <a:noFill/>
+        </p:spPr>
+        <p:txBody>
+          <a:bodyPr wrap="square">
+            <a:spAutoFit/>
+          </a:bodyPr>
+          <a:lstStyle/>
+          <a:p>
+            <a:pPr algn="r" rtl="1"/>
+            <a:r>
+              <a:rPr sz="3200" b="1">
+                <a:solidFill>
+                  <a:srgbClr val="1F3B5C"/>
+                </a:solidFill>
+                <a:latin typeface="Arial"/>
+              </a:rPr>
+              <a:t>إجابات الاختبار / Quiz Answers</a:t>
+            </a:r>
+          </a:p>
+        </p:txBody>
+      </p:sp>
+      <p:sp>
+        <p:nvSpPr>
+          <p:cNvPr id="4" name="TextBox 3"/>
+          <p:cNvSpPr txBox="1"/>
+          <p:nvPr/>
+        </p:nvSpPr>
+        <p:spPr>
+          <a:xfrm>
+            <a:off x="640080" y="1280160"/>
+            <a:ext cx="10972800" cy="5212080"/>
+          </a:xfrm>
+          <a:prstGeom prst="rect">
+            <a:avLst/>
+          </a:prstGeom>
+          <a:noFill/>
+        </p:spPr>
+        <p:txBody>
+          <a:bodyPr wrap="square">
+            <a:spAutoFit/>
+          </a:bodyPr>
+          <a:lstStyle/>
+          <a:p>
+            <a:pPr algn="r" rtl="1">
+              <a:spcBef>
+                <a:spcPts val="200"/>
+              </a:spcBef>
+              <a:spcAft>
+                <a:spcPts val="1000"/>
+              </a:spcAft>
+            </a:pPr>
+            <a:r>
+              <a:rPr sz="1800">
                 <a:solidFill>
                   <a:srgbClr val="333333"/>
                 </a:solidFill>
+                <a:latin typeface="Arial"/>
+              </a:rPr>
+              <a:t>• 1. لأن النموذج قد يخطئ أو يتحيز — التحقق البشري يضمن الجودة.</a:t>
+            </a:r>
+          </a:p>
+          <a:p>
+            <a:pPr algn="l" rtl="0">
+              <a:spcBef>
+                <a:spcPts val="200"/>
+              </a:spcBef>
+              <a:spcAft>
+                <a:spcPts val="1000"/>
+              </a:spcAft>
+            </a:pPr>
+            <a:r>
+              <a:rPr sz="1500">
+                <a:solidFill>
+                  <a:srgbClr val="666666"/>
+                </a:solidFill>
                 <a:latin typeface="Calibri"/>
               </a:rPr>
-              <a:t>بيانات خام</a:t>
-            </a:r>
-          </a:p>
-          <a:p>
-            <a:pPr algn="ctr" rtl="0"/>
-            <a:r>
-              <a:rPr sz="1200">
+              <a:t>• The model can err or be biased — human validation guarantees quality.</a:t>
+            </a:r>
+          </a:p>
+          <a:p>
+            <a:pPr algn="r" rtl="1">
+              <a:spcBef>
+                <a:spcPts val="200"/>
+              </a:spcBef>
+              <a:spcAft>
+                <a:spcPts val="1000"/>
+              </a:spcAft>
+            </a:pPr>
+            <a:r>
+              <a:rPr sz="1800">
+                <a:solidFill>
+                  <a:srgbClr val="333333"/>
+                </a:solidFill>
+                <a:latin typeface="Arial"/>
+              </a:rPr>
+              <a:t>• 2. Roboflow.</a:t>
+            </a:r>
+          </a:p>
+          <a:p>
+            <a:pPr algn="l" rtl="0">
+              <a:spcBef>
+                <a:spcPts val="200"/>
+              </a:spcBef>
+              <a:spcAft>
+                <a:spcPts val="1000"/>
+              </a:spcAft>
+            </a:pPr>
+            <a:r>
+              <a:rPr sz="1500">
                 <a:solidFill>
                   <a:srgbClr val="666666"/>
                 </a:solidFill>
                 <a:latin typeface="Calibri"/>
               </a:rPr>
-              <a:t>Raw data</a:t>
-            </a:r>
-          </a:p>
-        </p:txBody>
-      </p:sp>
-      <p:sp>
-        <p:nvSpPr>
-          <p:cNvPr id="4" name="Right Arrow 3"/>
+              <a:t>• Roboflow.</a:t>
+            </a:r>
+          </a:p>
+        </p:txBody>
+      </p:sp>
+      <p:sp>
+        <p:nvSpPr>
+          <p:cNvPr id="5" name="TextBox 4"/>
+          <p:cNvSpPr txBox="1"/>
+          <p:nvPr/>
+        </p:nvSpPr>
+        <p:spPr>
+          <a:xfrm>
+            <a:off x="640080" y="6400800"/>
+            <a:ext cx="8686800" cy="320040"/>
+          </a:xfrm>
+          <a:prstGeom prst="rect">
+            <a:avLst/>
+          </a:prstGeom>
+          <a:noFill/>
+        </p:spPr>
+        <p:txBody>
+          <a:bodyPr wrap="square">
+            <a:spAutoFit/>
+          </a:bodyPr>
+          <a:lstStyle/>
+          <a:p>
+            <a:pPr algn="r" rtl="1"/>
+            <a:r>
+              <a:rPr sz="1000" b="0">
+                <a:solidFill>
+                  <a:srgbClr val="666666"/>
+                </a:solidFill>
+                <a:latin typeface="Arial"/>
+              </a:rPr>
+              <a:t>Module 02 — Data &amp; AI Engineering Track  |  الوحدة الثانية</a:t>
+            </a:r>
+          </a:p>
+        </p:txBody>
+      </p:sp>
+      <p:sp>
+        <p:nvSpPr>
+          <p:cNvPr id="6" name="TextBox 5"/>
+          <p:cNvSpPr txBox="1"/>
+          <p:nvPr/>
+        </p:nvSpPr>
+        <p:spPr>
+          <a:xfrm>
+            <a:off x="9601200" y="6400800"/>
+            <a:ext cx="1920240" cy="320040"/>
+          </a:xfrm>
+          <a:prstGeom prst="rect">
+            <a:avLst/>
+          </a:prstGeom>
+          <a:noFill/>
+        </p:spPr>
+        <p:txBody>
+          <a:bodyPr wrap="square">
+            <a:spAutoFit/>
+          </a:bodyPr>
+          <a:lstStyle/>
+          <a:p>
+            <a:pPr algn="l" rtl="0"/>
+            <a:r>
+              <a:rPr sz="1000" b="0">
+                <a:solidFill>
+                  <a:srgbClr val="666666"/>
+                </a:solidFill>
+                <a:latin typeface="Calibri"/>
+              </a:rPr>
+              <a:t>V10  •  7/11</a:t>
+            </a:r>
+          </a:p>
+        </p:txBody>
+      </p:sp>
+      <p:sp>
+        <p:nvSpPr>
+          <p:cNvPr id="7" name="TextBox 6"/>
+          <p:cNvSpPr txBox="1"/>
+          <p:nvPr/>
+        </p:nvSpPr>
+        <p:spPr>
+          <a:xfrm>
+            <a:off x="640080" y="6400800"/>
+            <a:ext cx="8686800" cy="320040"/>
+          </a:xfrm>
+          <a:prstGeom prst="rect">
+            <a:avLst/>
+          </a:prstGeom>
+          <a:noFill/>
+        </p:spPr>
+        <p:txBody>
+          <a:bodyPr wrap="square">
+            <a:spAutoFit/>
+          </a:bodyPr>
+          <a:lstStyle/>
+          <a:p>
+            <a:pPr algn="r" rtl="1"/>
+            <a:r>
+              <a:rPr sz="1000" b="0">
+                <a:solidFill>
+                  <a:srgbClr val="666666"/>
+                </a:solidFill>
+                <a:latin typeface="Arial"/>
+              </a:rPr>
+              <a:t>Module 02 — Data &amp; AI Engineering Track  |  الوحدة الثانية</a:t>
+            </a:r>
+          </a:p>
+        </p:txBody>
+      </p:sp>
+      <p:sp>
+        <p:nvSpPr>
+          <p:cNvPr id="8" name="TextBox 7"/>
+          <p:cNvSpPr txBox="1"/>
+          <p:nvPr/>
+        </p:nvSpPr>
+        <p:spPr>
+          <a:xfrm>
+            <a:off x="9601200" y="6400800"/>
+            <a:ext cx="1920240" cy="320040"/>
+          </a:xfrm>
+          <a:prstGeom prst="rect">
+            <a:avLst/>
+          </a:prstGeom>
+          <a:noFill/>
+        </p:spPr>
+        <p:txBody>
+          <a:bodyPr wrap="square">
+            <a:spAutoFit/>
+          </a:bodyPr>
+          <a:lstStyle/>
+          <a:p>
+            <a:pPr algn="l" rtl="0"/>
+            <a:r>
+              <a:rPr sz="1000" b="0">
+                <a:solidFill>
+                  <a:srgbClr val="666666"/>
+                </a:solidFill>
+                <a:latin typeface="Calibri"/>
+              </a:rPr>
+              <a:t>10_  •  8/9</a:t>
+            </a:r>
+          </a:p>
+        </p:txBody>
+      </p:sp>
+      <p:sp>
+        <p:nvSpPr>
+          <p:cNvPr id="9" name="TextBox 8"/>
+          <p:cNvSpPr txBox="1"/>
+          <p:nvPr/>
+        </p:nvSpPr>
+        <p:spPr>
+          <a:xfrm>
+            <a:off x="640080" y="6400800"/>
+            <a:ext cx="8686800" cy="320040"/>
+          </a:xfrm>
+          <a:prstGeom prst="rect">
+            <a:avLst/>
+          </a:prstGeom>
+          <a:noFill/>
+        </p:spPr>
+        <p:txBody>
+          <a:bodyPr wrap="square">
+            <a:spAutoFit/>
+          </a:bodyPr>
+          <a:lstStyle/>
+          <a:p>
+            <a:pPr algn="r" rtl="1"/>
+            <a:r>
+              <a:rPr sz="1000" b="0">
+                <a:solidFill>
+                  <a:srgbClr val="666666"/>
+                </a:solidFill>
+                <a:latin typeface="Arial"/>
+              </a:rPr>
+              <a:t>Module 02 — Data &amp; AI Engineering Track  |  الوحدة الثانية</a:t>
+            </a:r>
+          </a:p>
+        </p:txBody>
+      </p:sp>
+      <p:sp>
+        <p:nvSpPr>
+          <p:cNvPr id="10" name="TextBox 9"/>
+          <p:cNvSpPr txBox="1"/>
+          <p:nvPr/>
+        </p:nvSpPr>
+        <p:spPr>
+          <a:xfrm>
+            <a:off x="9601200" y="6400800"/>
+            <a:ext cx="1920240" cy="320040"/>
+          </a:xfrm>
+          <a:prstGeom prst="rect">
+            <a:avLst/>
+          </a:prstGeom>
+          <a:noFill/>
+        </p:spPr>
+        <p:txBody>
+          <a:bodyPr wrap="square">
+            <a:spAutoFit/>
+          </a:bodyPr>
+          <a:lstStyle/>
+          <a:p>
+            <a:pPr algn="l" rtl="0"/>
+            <a:r>
+              <a:rPr sz="1000" b="0">
+                <a:solidFill>
+                  <a:srgbClr val="666666"/>
+                </a:solidFill>
+                <a:latin typeface="Calibri"/>
+              </a:rPr>
+              <a:t>10_  •  8/9</a:t>
+            </a:r>
+          </a:p>
+        </p:txBody>
+      </p:sp>
+    </p:spTree>
+  </p:cSld>
+  <p:clrMapOvr>
+    <a:masterClrMapping/>
+  </p:clrMapOvr>
+</p:sld>
+</file>
+
+<file path=ppt/slides/slide9.xml><?xml version="1.0" encoding="utf-8"?>
+<p:sld xmlns:a="http://schemas.openxmlformats.org/drawingml/2006/main" xmlns:p="http://schemas.openxmlformats.org/presentationml/2006/main" xmlns:r="http://schemas.openxmlformats.org/officeDocument/2006/relationships">
+  <p:cSld>
+    <p:bg>
+      <p:bgPr>
+        <a:solidFill>
+          <a:srgbClr val="FFFFFF"/>
+        </a:solidFill>
+        <a:effectLst/>
+      </p:bgPr>
+    </p:bg>
+    <p:spTree>
+      <p:nvGrpSpPr>
+        <p:cNvPr id="1" name=""/>
+        <p:cNvGrpSpPr/>
+        <p:nvPr/>
+      </p:nvGrpSpPr>
+      <p:grpSpPr/>
+      <p:sp>
+        <p:nvSpPr>
+          <p:cNvPr id="2" name="Rectangle 1"/>
           <p:cNvSpPr/>
           <p:nvPr/>
         </p:nvSpPr>
         <p:spPr>
           <a:xfrm>
-            <a:off x="2624328" y="2606040"/>
-            <a:ext cx="274320" cy="274320"/>
-          </a:xfrm>
-          <a:prstGeom prst="rightArrow">
+            <a:off x="0" y="0"/>
+            <a:ext cx="12191695" cy="1005840"/>
+          </a:xfrm>
+          <a:prstGeom prst="rect">
             <a:avLst/>
           </a:prstGeom>
           <a:solidFill>
-            <a:srgbClr val="1F4E79"/>
+            <a:srgbClr val="FFFFFF"/>
           </a:solidFill>
-          <a:ln>
-            <a:noFill/>
+          <a:ln w="25400">
+            <a:solidFill>
+              <a:srgbClr val="1F4E79"/>
+            </a:solidFill>
           </a:ln>
           <a:effectLst/>
         </p:spPr>
@@ -5003,481 +6822,14 @@
       </p:sp>
       <p:sp>
         <p:nvSpPr>
-          <p:cNvPr id="5" name="Rounded Rectangle 4"/>
-          <p:cNvSpPr/>
-          <p:nvPr/>
-        </p:nvSpPr>
-        <p:spPr>
-          <a:xfrm>
-            <a:off x="2926080" y="2103120"/>
-            <a:ext cx="1965960" cy="1280160"/>
-          </a:xfrm>
-          <a:prstGeom prst="roundRect">
-            <a:avLst/>
-          </a:prstGeom>
-          <a:solidFill>
-            <a:srgbClr val="DCE6F1"/>
-          </a:solidFill>
-          <a:ln w="12700">
-            <a:solidFill>
-              <a:srgbClr val="1F4E79"/>
-            </a:solidFill>
-          </a:ln>
-          <a:effectLst/>
-        </p:spPr>
-        <p:style>
-          <a:lnRef idx="1">
-            <a:schemeClr val="accent1"/>
-          </a:lnRef>
-          <a:fillRef idx="3">
-            <a:schemeClr val="accent1"/>
-          </a:fillRef>
-          <a:effectRef idx="2">
-            <a:schemeClr val="accent1"/>
-          </a:effectRef>
-          <a:fontRef idx="minor">
-            <a:schemeClr val="lt1"/>
-          </a:fontRef>
-        </p:style>
-        <p:txBody>
-          <a:bodyPr rtlCol="0" anchor="ctr" wrap="square"/>
-          <a:lstStyle/>
-          <a:p>
-            <a:pPr algn="ctr" rtl="1"/>
-            <a:r>
-              <a:rPr sz="1500" b="1">
-                <a:solidFill>
-                  <a:srgbClr val="333333"/>
-                </a:solidFill>
-                <a:latin typeface="Calibri"/>
-              </a:rPr>
-              <a:t>تسمية مبدئية بالـ LLM</a:t>
-            </a:r>
-          </a:p>
-          <a:p>
-            <a:pPr algn="ctr" rtl="0"/>
-            <a:r>
-              <a:rPr sz="1200">
-                <a:solidFill>
-                  <a:srgbClr val="666666"/>
-                </a:solidFill>
-                <a:latin typeface="Calibri"/>
-              </a:rPr>
-              <a:t>LLM pre-labeling</a:t>
-            </a:r>
-          </a:p>
-        </p:txBody>
-      </p:sp>
-      <p:sp>
-        <p:nvSpPr>
-          <p:cNvPr id="6" name="Right Arrow 5"/>
-          <p:cNvSpPr/>
-          <p:nvPr/>
-        </p:nvSpPr>
-        <p:spPr>
-          <a:xfrm>
-            <a:off x="4910328" y="2606040"/>
-            <a:ext cx="274320" cy="274320"/>
-          </a:xfrm>
-          <a:prstGeom prst="rightArrow">
-            <a:avLst/>
-          </a:prstGeom>
-          <a:solidFill>
-            <a:srgbClr val="1F4E79"/>
-          </a:solidFill>
-          <a:ln>
-            <a:noFill/>
-          </a:ln>
-          <a:effectLst/>
-        </p:spPr>
-        <p:style>
-          <a:lnRef idx="1">
-            <a:schemeClr val="accent1"/>
-          </a:lnRef>
-          <a:fillRef idx="3">
-            <a:schemeClr val="accent1"/>
-          </a:fillRef>
-          <a:effectRef idx="2">
-            <a:schemeClr val="accent1"/>
-          </a:effectRef>
-          <a:fontRef idx="minor">
-            <a:schemeClr val="lt1"/>
-          </a:fontRef>
-        </p:style>
-        <p:txBody>
-          <a:bodyPr rtlCol="0" anchor="ctr"/>
-          <a:lstStyle/>
-          <a:p>
-            <a:pPr algn="ctr"/>
-          </a:p>
-        </p:txBody>
-      </p:sp>
-      <p:sp>
-        <p:nvSpPr>
-          <p:cNvPr id="7" name="Rounded Rectangle 6"/>
-          <p:cNvSpPr/>
-          <p:nvPr/>
-        </p:nvSpPr>
-        <p:spPr>
-          <a:xfrm>
-            <a:off x="5212080" y="2103120"/>
-            <a:ext cx="1965960" cy="1280160"/>
-          </a:xfrm>
-          <a:prstGeom prst="roundRect">
-            <a:avLst/>
-          </a:prstGeom>
-          <a:solidFill>
-            <a:srgbClr val="E2EFDA"/>
-          </a:solidFill>
-          <a:ln w="12700">
-            <a:solidFill>
-              <a:srgbClr val="1F4E79"/>
-            </a:solidFill>
-          </a:ln>
-          <a:effectLst/>
-        </p:spPr>
-        <p:style>
-          <a:lnRef idx="1">
-            <a:schemeClr val="accent1"/>
-          </a:lnRef>
-          <a:fillRef idx="3">
-            <a:schemeClr val="accent1"/>
-          </a:fillRef>
-          <a:effectRef idx="2">
-            <a:schemeClr val="accent1"/>
-          </a:effectRef>
-          <a:fontRef idx="minor">
-            <a:schemeClr val="lt1"/>
-          </a:fontRef>
-        </p:style>
-        <p:txBody>
-          <a:bodyPr rtlCol="0" anchor="ctr" wrap="square"/>
-          <a:lstStyle/>
-          <a:p>
-            <a:pPr algn="ctr" rtl="1"/>
-            <a:r>
-              <a:rPr sz="1500" b="1">
-                <a:solidFill>
-                  <a:srgbClr val="333333"/>
-                </a:solidFill>
-                <a:latin typeface="Calibri"/>
-              </a:rPr>
-              <a:t>مراجعة وتصحيح بشري</a:t>
-            </a:r>
-          </a:p>
-          <a:p>
-            <a:pPr algn="ctr" rtl="0"/>
-            <a:r>
-              <a:rPr sz="1200">
-                <a:solidFill>
-                  <a:srgbClr val="666666"/>
-                </a:solidFill>
-                <a:latin typeface="Calibri"/>
-              </a:rPr>
-              <a:t>Human review (HITL)</a:t>
-            </a:r>
-          </a:p>
-        </p:txBody>
-      </p:sp>
-      <p:sp>
-        <p:nvSpPr>
-          <p:cNvPr id="8" name="Right Arrow 7"/>
-          <p:cNvSpPr/>
-          <p:nvPr/>
-        </p:nvSpPr>
-        <p:spPr>
-          <a:xfrm>
-            <a:off x="7196328" y="2606040"/>
-            <a:ext cx="274320" cy="274320"/>
-          </a:xfrm>
-          <a:prstGeom prst="rightArrow">
-            <a:avLst/>
-          </a:prstGeom>
-          <a:solidFill>
-            <a:srgbClr val="1F4E79"/>
-          </a:solidFill>
-          <a:ln>
-            <a:noFill/>
-          </a:ln>
-          <a:effectLst/>
-        </p:spPr>
-        <p:style>
-          <a:lnRef idx="1">
-            <a:schemeClr val="accent1"/>
-          </a:lnRef>
-          <a:fillRef idx="3">
-            <a:schemeClr val="accent1"/>
-          </a:fillRef>
-          <a:effectRef idx="2">
-            <a:schemeClr val="accent1"/>
-          </a:effectRef>
-          <a:fontRef idx="minor">
-            <a:schemeClr val="lt1"/>
-          </a:fontRef>
-        </p:style>
-        <p:txBody>
-          <a:bodyPr rtlCol="0" anchor="ctr"/>
-          <a:lstStyle/>
-          <a:p>
-            <a:pPr algn="ctr"/>
-          </a:p>
-        </p:txBody>
-      </p:sp>
-      <p:sp>
-        <p:nvSpPr>
-          <p:cNvPr id="9" name="Rounded Rectangle 8"/>
-          <p:cNvSpPr/>
-          <p:nvPr/>
-        </p:nvSpPr>
-        <p:spPr>
-          <a:xfrm>
-            <a:off x="7498080" y="2103120"/>
-            <a:ext cx="1965960" cy="1280160"/>
-          </a:xfrm>
-          <a:prstGeom prst="roundRect">
-            <a:avLst/>
-          </a:prstGeom>
-          <a:solidFill>
-            <a:srgbClr val="FDE9D9"/>
-          </a:solidFill>
-          <a:ln w="12700">
-            <a:solidFill>
-              <a:srgbClr val="1F4E79"/>
-            </a:solidFill>
-          </a:ln>
-          <a:effectLst/>
-        </p:spPr>
-        <p:style>
-          <a:lnRef idx="1">
-            <a:schemeClr val="accent1"/>
-          </a:lnRef>
-          <a:fillRef idx="3">
-            <a:schemeClr val="accent1"/>
-          </a:fillRef>
-          <a:effectRef idx="2">
-            <a:schemeClr val="accent1"/>
-          </a:effectRef>
-          <a:fontRef idx="minor">
-            <a:schemeClr val="lt1"/>
-          </a:fontRef>
-        </p:style>
-        <p:txBody>
-          <a:bodyPr rtlCol="0" anchor="ctr" wrap="square"/>
-          <a:lstStyle/>
-          <a:p>
-            <a:pPr algn="ctr" rtl="1"/>
-            <a:r>
-              <a:rPr sz="1500" b="1">
-                <a:solidFill>
-                  <a:srgbClr val="333333"/>
-                </a:solidFill>
-                <a:latin typeface="Calibri"/>
-              </a:rPr>
-              <a:t>تسميات معتمدة</a:t>
-            </a:r>
-          </a:p>
-          <a:p>
-            <a:pPr algn="ctr" rtl="0"/>
-            <a:r>
-              <a:rPr sz="1200">
-                <a:solidFill>
-                  <a:srgbClr val="666666"/>
-                </a:solidFill>
-                <a:latin typeface="Calibri"/>
-              </a:rPr>
-              <a:t>Approved labels</a:t>
-            </a:r>
-          </a:p>
-        </p:txBody>
-      </p:sp>
-      <p:sp>
-        <p:nvSpPr>
-          <p:cNvPr id="10" name="Right Arrow 9"/>
-          <p:cNvSpPr/>
-          <p:nvPr/>
-        </p:nvSpPr>
-        <p:spPr>
-          <a:xfrm>
-            <a:off x="9482328" y="2606040"/>
-            <a:ext cx="274320" cy="274320"/>
-          </a:xfrm>
-          <a:prstGeom prst="rightArrow">
-            <a:avLst/>
-          </a:prstGeom>
-          <a:solidFill>
-            <a:srgbClr val="1F4E79"/>
-          </a:solidFill>
-          <a:ln>
-            <a:noFill/>
-          </a:ln>
-          <a:effectLst/>
-        </p:spPr>
-        <p:style>
-          <a:lnRef idx="1">
-            <a:schemeClr val="accent1"/>
-          </a:lnRef>
-          <a:fillRef idx="3">
-            <a:schemeClr val="accent1"/>
-          </a:fillRef>
-          <a:effectRef idx="2">
-            <a:schemeClr val="accent1"/>
-          </a:effectRef>
-          <a:fontRef idx="minor">
-            <a:schemeClr val="lt1"/>
-          </a:fontRef>
-        </p:style>
-        <p:txBody>
-          <a:bodyPr rtlCol="0" anchor="ctr"/>
-          <a:lstStyle/>
-          <a:p>
-            <a:pPr algn="ctr"/>
-          </a:p>
-        </p:txBody>
-      </p:sp>
-      <p:sp>
-        <p:nvSpPr>
-          <p:cNvPr id="11" name="Rounded Rectangle 10"/>
-          <p:cNvSpPr/>
-          <p:nvPr/>
-        </p:nvSpPr>
-        <p:spPr>
-          <a:xfrm>
-            <a:off x="9784080" y="2103120"/>
-            <a:ext cx="1965960" cy="1280160"/>
-          </a:xfrm>
-          <a:prstGeom prst="roundRect">
-            <a:avLst/>
-          </a:prstGeom>
-          <a:solidFill>
-            <a:srgbClr val="EDEDED"/>
-          </a:solidFill>
-          <a:ln w="12700">
-            <a:solidFill>
-              <a:srgbClr val="1F4E79"/>
-            </a:solidFill>
-          </a:ln>
-          <a:effectLst/>
-        </p:spPr>
-        <p:style>
-          <a:lnRef idx="1">
-            <a:schemeClr val="accent1"/>
-          </a:lnRef>
-          <a:fillRef idx="3">
-            <a:schemeClr val="accent1"/>
-          </a:fillRef>
-          <a:effectRef idx="2">
-            <a:schemeClr val="accent1"/>
-          </a:effectRef>
-          <a:fontRef idx="minor">
-            <a:schemeClr val="lt1"/>
-          </a:fontRef>
-        </p:style>
-        <p:txBody>
-          <a:bodyPr rtlCol="0" anchor="ctr" wrap="square"/>
-          <a:lstStyle/>
-          <a:p>
-            <a:pPr algn="ctr" rtl="1"/>
-            <a:r>
-              <a:rPr sz="1500" b="1">
-                <a:solidFill>
-                  <a:srgbClr val="333333"/>
-                </a:solidFill>
-                <a:latin typeface="Calibri"/>
-              </a:rPr>
-              <a:t>تدريب النموذج</a:t>
-            </a:r>
-          </a:p>
-          <a:p>
-            <a:pPr algn="ctr" rtl="0"/>
-            <a:r>
-              <a:rPr sz="1200">
-                <a:solidFill>
-                  <a:srgbClr val="666666"/>
-                </a:solidFill>
-                <a:latin typeface="Calibri"/>
-              </a:rPr>
-              <a:t>Model training</a:t>
-            </a:r>
-          </a:p>
-        </p:txBody>
-      </p:sp>
-      <p:sp>
-        <p:nvSpPr>
-          <p:cNvPr id="12" name="Rounded Rectangle 11"/>
-          <p:cNvSpPr/>
-          <p:nvPr/>
-        </p:nvSpPr>
-        <p:spPr>
-          <a:xfrm>
-            <a:off x="2743200" y="4023360"/>
-            <a:ext cx="6766560" cy="731520"/>
-          </a:xfrm>
-          <a:prstGeom prst="roundRect">
-            <a:avLst/>
-          </a:prstGeom>
-          <a:solidFill>
-            <a:srgbClr val="EDEDED"/>
-          </a:solidFill>
-          <a:ln w="12700">
-            <a:solidFill>
-              <a:srgbClr val="1F4E79"/>
-            </a:solidFill>
-          </a:ln>
-          <a:effectLst/>
-        </p:spPr>
-        <p:style>
-          <a:lnRef idx="1">
-            <a:schemeClr val="accent1"/>
-          </a:lnRef>
-          <a:fillRef idx="3">
-            <a:schemeClr val="accent1"/>
-          </a:fillRef>
-          <a:effectRef idx="2">
-            <a:schemeClr val="accent1"/>
-          </a:effectRef>
-          <a:fontRef idx="minor">
-            <a:schemeClr val="lt1"/>
-          </a:fontRef>
-        </p:style>
-        <p:txBody>
-          <a:bodyPr rtlCol="0" anchor="ctr" wrap="square"/>
-          <a:lstStyle/>
-          <a:p>
-            <a:pPr algn="ctr" rtl="1"/>
-            <a:r>
-              <a:rPr sz="1300" b="1">
-                <a:solidFill>
-                  <a:srgbClr val="333333"/>
-                </a:solidFill>
-                <a:latin typeface="Calibri"/>
-              </a:rPr>
-              <a:t>حلقة تغذية راجعة: تصحيحات البشر تُحسِّن موجِّهات الـ LLM</a:t>
-            </a:r>
-          </a:p>
-          <a:p>
-            <a:pPr algn="ctr" rtl="0"/>
-            <a:r>
-              <a:rPr sz="1100">
-                <a:solidFill>
-                  <a:srgbClr val="666666"/>
-                </a:solidFill>
-                <a:latin typeface="Calibri"/>
-              </a:rPr>
-              <a:t>Feedback loop: human corrections improve LLM prompts</a:t>
-            </a:r>
-          </a:p>
-        </p:txBody>
-      </p:sp>
-      <p:sp>
-        <p:nvSpPr>
-          <p:cNvPr id="13" name="TextBox 12"/>
+          <p:cNvPr id="3" name="TextBox 2"/>
           <p:cNvSpPr txBox="1"/>
           <p:nvPr/>
         </p:nvSpPr>
         <p:spPr>
           <a:xfrm>
-            <a:off x="640080" y="6126480"/>
-            <a:ext cx="10972800" cy="548640"/>
+            <a:off x="640080" y="182880"/>
+            <a:ext cx="10972800" cy="640080"/>
           </a:xfrm>
           <a:prstGeom prst="rect">
             <a:avLst/>
@@ -5492,19 +6844,322 @@
           <a:p>
             <a:pPr algn="r" rtl="1"/>
             <a:r>
-              <a:rPr sz="1400">
+              <a:rPr sz="3200" b="1">
+                <a:solidFill>
+                  <a:srgbClr val="1F3B5C"/>
+                </a:solidFill>
+                <a:latin typeface="Arial"/>
+              </a:rPr>
+              <a:t>للاستزادة / Further Reading</a:t>
+            </a:r>
+          </a:p>
+        </p:txBody>
+      </p:sp>
+      <p:sp>
+        <p:nvSpPr>
+          <p:cNvPr id="4" name="TextBox 3"/>
+          <p:cNvSpPr txBox="1"/>
+          <p:nvPr/>
+        </p:nvSpPr>
+        <p:spPr>
+          <a:xfrm>
+            <a:off x="640080" y="1280160"/>
+            <a:ext cx="10972800" cy="5212080"/>
+          </a:xfrm>
+          <a:prstGeom prst="rect">
+            <a:avLst/>
+          </a:prstGeom>
+          <a:noFill/>
+        </p:spPr>
+        <p:txBody>
+          <a:bodyPr wrap="square">
+            <a:spAutoFit/>
+          </a:bodyPr>
+          <a:lstStyle/>
+          <a:p>
+            <a:pPr algn="r" rtl="1">
+              <a:spcBef>
+                <a:spcPts val="200"/>
+              </a:spcBef>
+              <a:spcAft>
+                <a:spcPts val="1000"/>
+              </a:spcAft>
+            </a:pPr>
+            <a:r>
+              <a:rPr sz="2000">
+                <a:solidFill>
+                  <a:srgbClr val="333333"/>
+                </a:solidFill>
+                <a:latin typeface="Arial"/>
+              </a:rPr>
+              <a:t>• توثيق Label Studio.</a:t>
+            </a:r>
+          </a:p>
+          <a:p>
+            <a:pPr algn="l" rtl="0">
+              <a:spcBef>
+                <a:spcPts val="200"/>
+              </a:spcBef>
+              <a:spcAft>
+                <a:spcPts val="1000"/>
+              </a:spcAft>
+            </a:pPr>
+            <a:r>
+              <a:rPr sz="1700">
                 <a:solidFill>
                   <a:srgbClr val="666666"/>
                 </a:solidFill>
                 <a:latin typeface="Calibri"/>
               </a:rPr>
-              <a:t>الـ LLM يسرّع التسمية والبشر يضمنون الجودة — أفضل الممارسات الحديثة.</a:t>
-            </a:r>
-          </a:p>
-          <a:p>
-            <a:pPr algn="r" rtl="0"/>
-            <a:r>
-              <a:t>LLM accelerates labeling; humans guarantee quality — modern best practice.</a:t>
+              <a:t>• Label Studio docs.</a:t>
+            </a:r>
+          </a:p>
+          <a:p>
+            <a:pPr algn="r" rtl="1">
+              <a:spcBef>
+                <a:spcPts val="200"/>
+              </a:spcBef>
+              <a:spcAft>
+                <a:spcPts val="1000"/>
+              </a:spcAft>
+            </a:pPr>
+            <a:r>
+              <a:rPr sz="2000">
+                <a:solidFill>
+                  <a:srgbClr val="333333"/>
+                </a:solidFill>
+                <a:latin typeface="Arial"/>
+              </a:rPr>
+              <a:t>• توثيق Roboflow.</a:t>
+            </a:r>
+          </a:p>
+          <a:p>
+            <a:pPr algn="l" rtl="0">
+              <a:spcBef>
+                <a:spcPts val="200"/>
+              </a:spcBef>
+              <a:spcAft>
+                <a:spcPts val="1000"/>
+              </a:spcAft>
+            </a:pPr>
+            <a:r>
+              <a:rPr sz="1700">
+                <a:solidFill>
+                  <a:srgbClr val="666666"/>
+                </a:solidFill>
+                <a:latin typeface="Calibri"/>
+              </a:rPr>
+              <a:t>• Roboflow docs.</a:t>
+            </a:r>
+          </a:p>
+        </p:txBody>
+      </p:sp>
+      <p:sp>
+        <p:nvSpPr>
+          <p:cNvPr id="5" name="TextBox 4"/>
+          <p:cNvSpPr txBox="1"/>
+          <p:nvPr/>
+        </p:nvSpPr>
+        <p:spPr>
+          <a:xfrm>
+            <a:off x="640080" y="6400800"/>
+            <a:ext cx="8686800" cy="320040"/>
+          </a:xfrm>
+          <a:prstGeom prst="rect">
+            <a:avLst/>
+          </a:prstGeom>
+          <a:noFill/>
+        </p:spPr>
+        <p:txBody>
+          <a:bodyPr wrap="square">
+            <a:spAutoFit/>
+          </a:bodyPr>
+          <a:lstStyle/>
+          <a:p>
+            <a:pPr algn="r" rtl="1"/>
+            <a:r>
+              <a:rPr sz="1000" b="0">
+                <a:solidFill>
+                  <a:srgbClr val="666666"/>
+                </a:solidFill>
+                <a:latin typeface="Arial"/>
+              </a:rPr>
+              <a:t>Module 02 — Data &amp; AI Engineering Track  |  الوحدة الثانية</a:t>
+            </a:r>
+          </a:p>
+        </p:txBody>
+      </p:sp>
+      <p:sp>
+        <p:nvSpPr>
+          <p:cNvPr id="6" name="TextBox 5"/>
+          <p:cNvSpPr txBox="1"/>
+          <p:nvPr/>
+        </p:nvSpPr>
+        <p:spPr>
+          <a:xfrm>
+            <a:off x="9601200" y="6400800"/>
+            <a:ext cx="1920240" cy="320040"/>
+          </a:xfrm>
+          <a:prstGeom prst="rect">
+            <a:avLst/>
+          </a:prstGeom>
+          <a:noFill/>
+        </p:spPr>
+        <p:txBody>
+          <a:bodyPr wrap="square">
+            <a:spAutoFit/>
+          </a:bodyPr>
+          <a:lstStyle/>
+          <a:p>
+            <a:pPr algn="l" rtl="0"/>
+            <a:r>
+              <a:rPr sz="1000" b="0">
+                <a:solidFill>
+                  <a:srgbClr val="666666"/>
+                </a:solidFill>
+                <a:latin typeface="Calibri"/>
+              </a:rPr>
+              <a:t>V10  •  8/11</a:t>
+            </a:r>
+          </a:p>
+        </p:txBody>
+      </p:sp>
+      <p:sp>
+        <p:nvSpPr>
+          <p:cNvPr id="7" name="TextBox 6"/>
+          <p:cNvSpPr txBox="1"/>
+          <p:nvPr/>
+        </p:nvSpPr>
+        <p:spPr>
+          <a:xfrm>
+            <a:off x="640080" y="6400800"/>
+            <a:ext cx="8686800" cy="320040"/>
+          </a:xfrm>
+          <a:prstGeom prst="rect">
+            <a:avLst/>
+          </a:prstGeom>
+          <a:noFill/>
+        </p:spPr>
+        <p:txBody>
+          <a:bodyPr wrap="square">
+            <a:spAutoFit/>
+          </a:bodyPr>
+          <a:lstStyle/>
+          <a:p>
+            <a:pPr algn="r" rtl="1"/>
+            <a:r>
+              <a:rPr sz="1000" b="0">
+                <a:solidFill>
+                  <a:srgbClr val="666666"/>
+                </a:solidFill>
+                <a:latin typeface="Arial"/>
+              </a:rPr>
+              <a:t>Module 02 — Data &amp; AI Engineering Track  |  الوحدة الثانية</a:t>
+            </a:r>
+          </a:p>
+        </p:txBody>
+      </p:sp>
+      <p:sp>
+        <p:nvSpPr>
+          <p:cNvPr id="8" name="TextBox 7"/>
+          <p:cNvSpPr txBox="1"/>
+          <p:nvPr/>
+        </p:nvSpPr>
+        <p:spPr>
+          <a:xfrm>
+            <a:off x="9601200" y="6400800"/>
+            <a:ext cx="1920240" cy="320040"/>
+          </a:xfrm>
+          <a:prstGeom prst="rect">
+            <a:avLst/>
+          </a:prstGeom>
+          <a:noFill/>
+        </p:spPr>
+        <p:txBody>
+          <a:bodyPr wrap="square">
+            <a:spAutoFit/>
+          </a:bodyPr>
+          <a:lstStyle/>
+          <a:p>
+            <a:pPr algn="l" rtl="0"/>
+            <a:r>
+              <a:rPr sz="1000" b="0">
+                <a:solidFill>
+                  <a:srgbClr val="666666"/>
+                </a:solidFill>
+                <a:latin typeface="Calibri"/>
+              </a:rPr>
+              <a:t>10_  •  9/9</a:t>
+            </a:r>
+          </a:p>
+        </p:txBody>
+      </p:sp>
+      <p:sp>
+        <p:nvSpPr>
+          <p:cNvPr id="9" name="TextBox 8"/>
+          <p:cNvSpPr txBox="1"/>
+          <p:nvPr/>
+        </p:nvSpPr>
+        <p:spPr>
+          <a:xfrm>
+            <a:off x="640080" y="6400800"/>
+            <a:ext cx="8686800" cy="320040"/>
+          </a:xfrm>
+          <a:prstGeom prst="rect">
+            <a:avLst/>
+          </a:prstGeom>
+          <a:noFill/>
+        </p:spPr>
+        <p:txBody>
+          <a:bodyPr wrap="square">
+            <a:spAutoFit/>
+          </a:bodyPr>
+          <a:lstStyle/>
+          <a:p>
+            <a:pPr algn="r" rtl="1"/>
+            <a:r>
+              <a:rPr sz="1000" b="0">
+                <a:solidFill>
+                  <a:srgbClr val="666666"/>
+                </a:solidFill>
+                <a:latin typeface="Arial"/>
+              </a:rPr>
+              <a:t>Module 02 — Data &amp; AI Engineering Track  |  الوحدة الثانية</a:t>
+            </a:r>
+          </a:p>
+        </p:txBody>
+      </p:sp>
+      <p:sp>
+        <p:nvSpPr>
+          <p:cNvPr id="10" name="TextBox 9"/>
+          <p:cNvSpPr txBox="1"/>
+          <p:nvPr/>
+        </p:nvSpPr>
+        <p:spPr>
+          <a:xfrm>
+            <a:off x="9601200" y="6400800"/>
+            <a:ext cx="1920240" cy="320040"/>
+          </a:xfrm>
+          <a:prstGeom prst="rect">
+            <a:avLst/>
+          </a:prstGeom>
+          <a:noFill/>
+        </p:spPr>
+        <p:txBody>
+          <a:bodyPr wrap="square">
+            <a:spAutoFit/>
+          </a:bodyPr>
+          <a:lstStyle/>
+          <a:p>
+            <a:pPr algn="l" rtl="0"/>
+            <a:r>
+              <a:rPr sz="1000" b="0">
+                <a:solidFill>
+                  <a:srgbClr val="666666"/>
+                </a:solidFill>
+                <a:latin typeface="Calibri"/>
+              </a:rPr>
+              <a:t>10_  •  9/9</a:t>
             </a:r>
           </a:p>
         </p:txBody>

</xml_diff>